<commit_message>
fix: bind format validation to generated artifacts
</commit_message>
<xml_diff>
--- a/tests/formats/output/career-entry-12-week-roadmap/brief.pptx
+++ b/tests/formats/output/career-entry-12-week-roadmap/brief.pptx
@@ -2,18 +2,18 @@
 <file path=ppt/presentation.xml><?xml version="1.0" encoding="utf-8"?>
 <p:presentation xmlns:p="http://schemas.openxmlformats.org/presentationml/2006/main">
   <p:sldMasterIdLst>
-    <p:sldMasterId xmlns:r="http://schemas.openxmlformats.org/officeDocument/2006/relationships" id="2147483648" r:id="Ra6e78ca7a9724b06"/>
+    <p:sldMasterId xmlns:r="http://schemas.openxmlformats.org/officeDocument/2006/relationships" id="2147483648" r:id="Rdd4d2a92b56547c4"/>
   </p:sldMasterIdLst>
   <p:notesMasterIdLst>
-    <p:notesMasterId xmlns:r="http://schemas.openxmlformats.org/officeDocument/2006/relationships" r:id="R698b0e659b6a4a69"/>
+    <p:notesMasterId xmlns:r="http://schemas.openxmlformats.org/officeDocument/2006/relationships" r:id="Rc8daef980f2f4d56"/>
   </p:notesMasterIdLst>
   <p:sldIdLst>
-    <p:sldId xmlns:r="http://schemas.openxmlformats.org/officeDocument/2006/relationships" id="256" r:id="R99e4f08f82734e91"/>
-    <p:sldId xmlns:r="http://schemas.openxmlformats.org/officeDocument/2006/relationships" id="257" r:id="R6148ef0c483d4599"/>
-    <p:sldId xmlns:r="http://schemas.openxmlformats.org/officeDocument/2006/relationships" id="258" r:id="R5a723ca1b7e245b8"/>
-    <p:sldId xmlns:r="http://schemas.openxmlformats.org/officeDocument/2006/relationships" id="259" r:id="R306bf8865b104046"/>
-    <p:sldId xmlns:r="http://schemas.openxmlformats.org/officeDocument/2006/relationships" id="260" r:id="R891fc2c3355741fb"/>
-    <p:sldId xmlns:r="http://schemas.openxmlformats.org/officeDocument/2006/relationships" id="261" r:id="Rc8330041faa14c4a"/>
+    <p:sldId xmlns:r="http://schemas.openxmlformats.org/officeDocument/2006/relationships" id="256" r:id="Rf6382d2a775a4ef7"/>
+    <p:sldId xmlns:r="http://schemas.openxmlformats.org/officeDocument/2006/relationships" id="257" r:id="Re0e45f106fa94b56"/>
+    <p:sldId xmlns:r="http://schemas.openxmlformats.org/officeDocument/2006/relationships" id="258" r:id="Rcce85fe153144e89"/>
+    <p:sldId xmlns:r="http://schemas.openxmlformats.org/officeDocument/2006/relationships" id="259" r:id="Rf092ac4782ad4965"/>
+    <p:sldId xmlns:r="http://schemas.openxmlformats.org/officeDocument/2006/relationships" id="260" r:id="Rb3e576730eb7473d"/>
+    <p:sldId xmlns:r="http://schemas.openxmlformats.org/officeDocument/2006/relationships" id="261" r:id="R2c3cdc6f57084467"/>
   </p:sldIdLst>
   <p:sldSz cx="12192000" cy="6858000"/>
   <p:notesSz cx="6858000" cy="9144000"/>
@@ -452,7 +452,7 @@
           </a:p>
           <a:p xmlns:a="http://schemas.openxmlformats.org/drawingml/2006/main">
             <a:r>
-              <a:t>- request.json#/</a:t>
+              <a:t>- request.json#/availableHoursPerWeek</a:t>
             </a:r>
           </a:p>
         </p:txBody>
@@ -900,7 +900,7 @@
   </p:cSld>
   <p:clrMap bg1="lt1" tx1="dk1" bg2="lt2" tx2="dk2" accent1="accent1" accent2="accent2" accent3="accent3" accent4="accent4" accent5="accent5" accent6="accent6" hlink="hlink" folHlink="folHlink"/>
   <p:sldLayoutIdLst>
-    <p:sldLayoutId xmlns:r="http://schemas.openxmlformats.org/officeDocument/2006/relationships" id="2147483649" r:id="R2d2540d0f3bc44ce"/>
+    <p:sldLayoutId xmlns:r="http://schemas.openxmlformats.org/officeDocument/2006/relationships" id="2147483649" r:id="R5ba5730672c74d80"/>
   </p:sldLayoutIdLst>
   <p:txStyles>
     <p:titleStyle>
@@ -1451,7 +1451,7 @@
           <p:cNvPr id="7" name="cover-kicker">
             <a:extLst xmlns:a="http://schemas.openxmlformats.org/drawingml/2006/main">
               <a:ext uri="{FF2B5EF4-FFF2-40B4-BE49-F238E27FC236}">
-                <a16:creationId xmlns:a16="http://schemas.microsoft.com/office/drawing/2014/main" id="{29E16C52-C28C-479E-BC42-BA33A846648E}"/>
+                <a16:creationId xmlns:a16="http://schemas.microsoft.com/office/drawing/2014/main" id="{FCE9152B-EB0A-4896-973C-750E49462115}"/>
               </a:ext>
             </a:extLst>
           </p:cNvPr>
@@ -1509,7 +1509,7 @@
           <p:cNvPr id="2" name="cover-title">
             <a:extLst xmlns:a="http://schemas.openxmlformats.org/drawingml/2006/main">
               <a:ext uri="{FF2B5EF4-FFF2-40B4-BE49-F238E27FC236}">
-                <a16:creationId xmlns:a16="http://schemas.microsoft.com/office/drawing/2014/main" id="{180D2693-CBFC-407C-A6E6-6795F42EF341}"/>
+                <a16:creationId xmlns:a16="http://schemas.microsoft.com/office/drawing/2014/main" id="{915FCC00-BB1C-48EF-83D4-2C0794E04A3A}"/>
               </a:ext>
             </a:extLst>
           </p:cNvPr>
@@ -1590,7 +1590,7 @@
           <p:cNvPr id="3" name="cover-subtitle">
             <a:extLst xmlns:a="http://schemas.openxmlformats.org/drawingml/2006/main">
               <a:ext uri="{FF2B5EF4-FFF2-40B4-BE49-F238E27FC236}">
-                <a16:creationId xmlns:a16="http://schemas.microsoft.com/office/drawing/2014/main" id="{2DA5B42C-E98B-4CD1-B7D8-85D3359CBBD7}"/>
+                <a16:creationId xmlns:a16="http://schemas.microsoft.com/office/drawing/2014/main" id="{B530B0DA-7F01-4E0C-9EA6-48426B087D78}"/>
               </a:ext>
             </a:extLst>
           </p:cNvPr>
@@ -1648,7 +1648,7 @@
           <p:cNvPr id="4" name="cover-panel">
             <a:extLst xmlns:a="http://schemas.openxmlformats.org/drawingml/2006/main">
               <a:ext uri="{FF2B5EF4-FFF2-40B4-BE49-F238E27FC236}">
-                <a16:creationId xmlns:a16="http://schemas.microsoft.com/office/drawing/2014/main" id="{58334EA1-D6E1-4399-8994-599F031A1DBB}"/>
+                <a16:creationId xmlns:a16="http://schemas.microsoft.com/office/drawing/2014/main" id="{99CE7C0C-360B-4A80-BEFF-B5D6E597A1BD}"/>
               </a:ext>
             </a:extLst>
           </p:cNvPr>
@@ -1662,10 +1662,8 @@
             <a:off x="8286750" y="514350"/>
             <a:ext cx="3143250" cy="5334000"/>
           </a:xfrm>
-          <a:prstGeom xmlns:a="http://schemas.openxmlformats.org/drawingml/2006/main" prst="roundRect">
-            <a:avLst>
-              <a:gd name="adj" fmla="val 2424"/>
-            </a:avLst>
+          <a:prstGeom xmlns:a="http://schemas.openxmlformats.org/drawingml/2006/main" prst="rect">
+            <a:avLst/>
           </a:prstGeom>
           <a:solidFill xmlns:a="http://schemas.openxmlformats.org/drawingml/2006/main">
             <a:srgbClr val="D0EDFA"/>
@@ -1683,7 +1681,7 @@
           <p:cNvPr id="5" name="cover-mark">
             <a:extLst xmlns:a="http://schemas.openxmlformats.org/drawingml/2006/main">
               <a:ext uri="{FF2B5EF4-FFF2-40B4-BE49-F238E27FC236}">
-                <a16:creationId xmlns:a16="http://schemas.microsoft.com/office/drawing/2014/main" id="{73DE99DE-C9EC-40E8-999D-983168962021}"/>
+                <a16:creationId xmlns:a16="http://schemas.microsoft.com/office/drawing/2014/main" id="{F00472AD-560D-482E-847B-D832591AE7AB}"/>
               </a:ext>
             </a:extLst>
           </p:cNvPr>
@@ -1741,7 +1739,7 @@
           <p:cNvPr id="6" name="cover-caption">
             <a:extLst xmlns:a="http://schemas.openxmlformats.org/drawingml/2006/main">
               <a:ext uri="{FF2B5EF4-FFF2-40B4-BE49-F238E27FC236}">
-                <a16:creationId xmlns:a16="http://schemas.microsoft.com/office/drawing/2014/main" id="{8551D71D-8B29-4080-9DB6-7190DB409268}"/>
+                <a16:creationId xmlns:a16="http://schemas.microsoft.com/office/drawing/2014/main" id="{2A128BEF-D6CF-4351-ADD9-54797E9DAF83}"/>
               </a:ext>
             </a:extLst>
           </p:cNvPr>
@@ -1797,7 +1795,7 @@
     </p:spTree>
     <p:extLst>
       <p:ext uri="{BB962C8B-B14F-4D97-AF65-F5344CB8AC3E}">
-        <p14:creationId xmlns:p14="http://schemas.microsoft.com/office/powerpoint/2010/main" val="1087747513"/>
+        <p14:creationId xmlns:p14="http://schemas.microsoft.com/office/powerpoint/2010/main" val="1518344835"/>
       </p:ext>
     </p:extLst>
   </p:cSld>
@@ -1828,7 +1826,7 @@
           <p:cNvPr id="7" name="title-2">
             <a:extLst xmlns:a="http://schemas.openxmlformats.org/drawingml/2006/main">
               <a:ext uri="{FF2B5EF4-FFF2-40B4-BE49-F238E27FC236}">
-                <a16:creationId xmlns:a16="http://schemas.microsoft.com/office/drawing/2014/main" id="{3948CC83-D2AD-4420-8E99-5335143BE173}"/>
+                <a16:creationId xmlns:a16="http://schemas.microsoft.com/office/drawing/2014/main" id="{F52121A7-D5F5-4CA6-950A-7324A9B38167}"/>
               </a:ext>
             </a:extLst>
           </p:cNvPr>
@@ -1886,7 +1884,7 @@
           <p:cNvPr id="2" name="number-2">
             <a:extLst xmlns:a="http://schemas.openxmlformats.org/drawingml/2006/main">
               <a:ext uri="{FF2B5EF4-FFF2-40B4-BE49-F238E27FC236}">
-                <a16:creationId xmlns:a16="http://schemas.microsoft.com/office/drawing/2014/main" id="{22A6D499-525F-4E5B-A945-39B84612163B}"/>
+                <a16:creationId xmlns:a16="http://schemas.microsoft.com/office/drawing/2014/main" id="{2E57B199-404A-405D-AF14-0AC3BA192BA0}"/>
               </a:ext>
             </a:extLst>
           </p:cNvPr>
@@ -1944,7 +1942,7 @@
           <p:cNvPr id="3" name="half-body">
             <a:extLst xmlns:a="http://schemas.openxmlformats.org/drawingml/2006/main">
               <a:ext uri="{FF2B5EF4-FFF2-40B4-BE49-F238E27FC236}">
-                <a16:creationId xmlns:a16="http://schemas.microsoft.com/office/drawing/2014/main" id="{24D6C739-7458-4807-957A-0CE36BB648BF}"/>
+                <a16:creationId xmlns:a16="http://schemas.microsoft.com/office/drawing/2014/main" id="{475B5AF3-E713-47F6-867C-59A00FA2C9D4}"/>
               </a:ext>
             </a:extLst>
           </p:cNvPr>
@@ -2002,7 +2000,7 @@
           <p:cNvPr id="4" name="half-visual">
             <a:extLst xmlns:a="http://schemas.openxmlformats.org/drawingml/2006/main">
               <a:ext uri="{FF2B5EF4-FFF2-40B4-BE49-F238E27FC236}">
-                <a16:creationId xmlns:a16="http://schemas.microsoft.com/office/drawing/2014/main" id="{E26BD3A8-134A-4EEA-B57F-0FF44137ABB5}"/>
+                <a16:creationId xmlns:a16="http://schemas.microsoft.com/office/drawing/2014/main" id="{8AA94C4D-4238-4551-85DA-5A6D16DF4ABF}"/>
               </a:ext>
             </a:extLst>
           </p:cNvPr>
@@ -2016,10 +2014,8 @@
             <a:off x="6286500" y="1381125"/>
             <a:ext cx="5505450" cy="4572000"/>
           </a:xfrm>
-          <a:prstGeom xmlns:a="http://schemas.openxmlformats.org/drawingml/2006/main" prst="roundRect">
-            <a:avLst>
-              <a:gd name="adj" fmla="val 1667"/>
-            </a:avLst>
+          <a:prstGeom xmlns:a="http://schemas.openxmlformats.org/drawingml/2006/main" prst="rect">
+            <a:avLst/>
           </a:prstGeom>
           <a:solidFill xmlns:a="http://schemas.openxmlformats.org/drawingml/2006/main">
             <a:srgbClr val="EAF5FB"/>
@@ -2037,7 +2033,7 @@
           <p:cNvPr id="5" name="half-signal">
             <a:extLst xmlns:a="http://schemas.openxmlformats.org/drawingml/2006/main">
               <a:ext uri="{FF2B5EF4-FFF2-40B4-BE49-F238E27FC236}">
-                <a16:creationId xmlns:a16="http://schemas.microsoft.com/office/drawing/2014/main" id="{D3932D79-2487-4E39-8BA6-84958BEF26DB}"/>
+                <a16:creationId xmlns:a16="http://schemas.microsoft.com/office/drawing/2014/main" id="{BEFE9C8D-4683-4A53-993D-87E489B80183}"/>
               </a:ext>
             </a:extLst>
           </p:cNvPr>
@@ -2095,7 +2091,7 @@
           <p:cNvPr id="6" name="half-caption">
             <a:extLst xmlns:a="http://schemas.openxmlformats.org/drawingml/2006/main">
               <a:ext uri="{FF2B5EF4-FFF2-40B4-BE49-F238E27FC236}">
-                <a16:creationId xmlns:a16="http://schemas.microsoft.com/office/drawing/2014/main" id="{D7EA0DF2-DA4A-414F-AAEB-05FCA22CE1E3}"/>
+                <a16:creationId xmlns:a16="http://schemas.microsoft.com/office/drawing/2014/main" id="{0241D644-0A69-4168-B1DD-AB3A53D40B16}"/>
               </a:ext>
             </a:extLst>
           </p:cNvPr>
@@ -2151,7 +2147,7 @@
     </p:spTree>
     <p:extLst>
       <p:ext uri="{BB962C8B-B14F-4D97-AF65-F5344CB8AC3E}">
-        <p14:creationId xmlns:p14="http://schemas.microsoft.com/office/powerpoint/2010/main" val="391553514"/>
+        <p14:creationId xmlns:p14="http://schemas.microsoft.com/office/powerpoint/2010/main" val="1351043623"/>
       </p:ext>
     </p:extLst>
   </p:cSld>
@@ -2182,7 +2178,7 @@
           <p:cNvPr id="9" name="title-3">
             <a:extLst xmlns:a="http://schemas.openxmlformats.org/drawingml/2006/main">
               <a:ext uri="{FF2B5EF4-FFF2-40B4-BE49-F238E27FC236}">
-                <a16:creationId xmlns:a16="http://schemas.microsoft.com/office/drawing/2014/main" id="{619F3A03-94C5-4768-8278-FAA66A852018}"/>
+                <a16:creationId xmlns:a16="http://schemas.microsoft.com/office/drawing/2014/main" id="{6D32C545-596D-4D1A-93DD-1FB3DE5D82DF}"/>
               </a:ext>
             </a:extLst>
           </p:cNvPr>
@@ -2240,7 +2236,7 @@
           <p:cNvPr id="2" name="number-3">
             <a:extLst xmlns:a="http://schemas.openxmlformats.org/drawingml/2006/main">
               <a:ext uri="{FF2B5EF4-FFF2-40B4-BE49-F238E27FC236}">
-                <a16:creationId xmlns:a16="http://schemas.microsoft.com/office/drawing/2014/main" id="{13EBC154-2386-49CF-A867-3D6B4E0D91DC}"/>
+                <a16:creationId xmlns:a16="http://schemas.microsoft.com/office/drawing/2014/main" id="{BCAD99B7-A759-4006-8C3D-1F188F57234C}"/>
               </a:ext>
             </a:extLst>
           </p:cNvPr>
@@ -2298,7 +2294,7 @@
           <p:cNvPr id="3" name="connector-1">
             <a:extLst xmlns:a="http://schemas.openxmlformats.org/drawingml/2006/main">
               <a:ext uri="{FF2B5EF4-FFF2-40B4-BE49-F238E27FC236}">
-                <a16:creationId xmlns:a16="http://schemas.microsoft.com/office/drawing/2014/main" id="{4ACA41CD-74A0-45C8-9FAA-DB5D7555E6D8}"/>
+                <a16:creationId xmlns:a16="http://schemas.microsoft.com/office/drawing/2014/main" id="{9DE9C668-07FC-4447-81DD-B05085415190}"/>
               </a:ext>
             </a:extLst>
           </p:cNvPr>
@@ -2329,7 +2325,7 @@
           <p:cNvPr id="4" name="connector-2">
             <a:extLst xmlns:a="http://schemas.openxmlformats.org/drawingml/2006/main">
               <a:ext uri="{FF2B5EF4-FFF2-40B4-BE49-F238E27FC236}">
-                <a16:creationId xmlns:a16="http://schemas.microsoft.com/office/drawing/2014/main" id="{2089DAD3-457F-4386-838C-BA04A5D84176}"/>
+                <a16:creationId xmlns:a16="http://schemas.microsoft.com/office/drawing/2014/main" id="{54402646-ABD8-496C-81C2-7B74064385AF}"/>
               </a:ext>
             </a:extLst>
           </p:cNvPr>
@@ -2360,7 +2356,7 @@
           <p:cNvPr id="5" name="node-1">
             <a:extLst xmlns:a="http://schemas.openxmlformats.org/drawingml/2006/main">
               <a:ext uri="{FF2B5EF4-FFF2-40B4-BE49-F238E27FC236}">
-                <a16:creationId xmlns:a16="http://schemas.microsoft.com/office/drawing/2014/main" id="{F535C0F7-C17D-4798-A5AD-5A0DECC28B4F}"/>
+                <a16:creationId xmlns:a16="http://schemas.microsoft.com/office/drawing/2014/main" id="{0C622E16-C8B5-48ED-A71F-E454086CEF95}"/>
               </a:ext>
             </a:extLst>
           </p:cNvPr>
@@ -2374,10 +2370,8 @@
             <a:off x="666750" y="2381250"/>
             <a:ext cx="2476500" cy="1619250"/>
           </a:xfrm>
-          <a:prstGeom xmlns:a="http://schemas.openxmlformats.org/drawingml/2006/main" prst="roundRect">
-            <a:avLst>
-              <a:gd name="adj" fmla="val 4706"/>
-            </a:avLst>
+          <a:prstGeom xmlns:a="http://schemas.openxmlformats.org/drawingml/2006/main" prst="rect">
+            <a:avLst/>
           </a:prstGeom>
           <a:solidFill xmlns:a="http://schemas.openxmlformats.org/drawingml/2006/main">
             <a:srgbClr val="EDEDED"/>
@@ -2424,7 +2418,7 @@
           <p:cNvPr id="6" name="node-2">
             <a:extLst xmlns:a="http://schemas.openxmlformats.org/drawingml/2006/main">
               <a:ext uri="{FF2B5EF4-FFF2-40B4-BE49-F238E27FC236}">
-                <a16:creationId xmlns:a16="http://schemas.microsoft.com/office/drawing/2014/main" id="{3F2D1DE7-2327-4E72-A1E2-F2CF06DAB8B1}"/>
+                <a16:creationId xmlns:a16="http://schemas.microsoft.com/office/drawing/2014/main" id="{CD8733FA-A8A2-495C-9739-DF8A665A9860}"/>
               </a:ext>
             </a:extLst>
           </p:cNvPr>
@@ -2438,10 +2432,8 @@
             <a:off x="3810000" y="2381250"/>
             <a:ext cx="2476500" cy="1619250"/>
           </a:xfrm>
-          <a:prstGeom xmlns:a="http://schemas.openxmlformats.org/drawingml/2006/main" prst="roundRect">
-            <a:avLst>
-              <a:gd name="adj" fmla="val 4706"/>
-            </a:avLst>
+          <a:prstGeom xmlns:a="http://schemas.openxmlformats.org/drawingml/2006/main" prst="rect">
+            <a:avLst/>
           </a:prstGeom>
           <a:solidFill xmlns:a="http://schemas.openxmlformats.org/drawingml/2006/main">
             <a:srgbClr val="D0EDFA"/>
@@ -2488,7 +2480,7 @@
           <p:cNvPr id="7" name="node-3">
             <a:extLst xmlns:a="http://schemas.openxmlformats.org/drawingml/2006/main">
               <a:ext uri="{FF2B5EF4-FFF2-40B4-BE49-F238E27FC236}">
-                <a16:creationId xmlns:a16="http://schemas.microsoft.com/office/drawing/2014/main" id="{9B3585B5-5ADF-4E12-BF2E-4C297C25A2A3}"/>
+                <a16:creationId xmlns:a16="http://schemas.microsoft.com/office/drawing/2014/main" id="{7E6F51C6-C2F7-4651-989E-01563FF9433F}"/>
               </a:ext>
             </a:extLst>
           </p:cNvPr>
@@ -2502,10 +2494,8 @@
             <a:off x="6953250" y="2381250"/>
             <a:ext cx="2476500" cy="1619250"/>
           </a:xfrm>
-          <a:prstGeom xmlns:a="http://schemas.openxmlformats.org/drawingml/2006/main" prst="roundRect">
-            <a:avLst>
-              <a:gd name="adj" fmla="val 4706"/>
-            </a:avLst>
+          <a:prstGeom xmlns:a="http://schemas.openxmlformats.org/drawingml/2006/main" prst="rect">
+            <a:avLst/>
           </a:prstGeom>
           <a:solidFill xmlns:a="http://schemas.openxmlformats.org/drawingml/2006/main">
             <a:srgbClr val="EDEDED"/>
@@ -2552,7 +2542,7 @@
           <p:cNvPr id="8" name="diagram-footer">
             <a:extLst xmlns:a="http://schemas.openxmlformats.org/drawingml/2006/main">
               <a:ext uri="{FF2B5EF4-FFF2-40B4-BE49-F238E27FC236}">
-                <a16:creationId xmlns:a16="http://schemas.microsoft.com/office/drawing/2014/main" id="{7B90617B-2569-48E3-8B64-14CBDA357EAC}"/>
+                <a16:creationId xmlns:a16="http://schemas.microsoft.com/office/drawing/2014/main" id="{3FED12E3-136D-45AD-91A9-EA6D0A16C588}"/>
               </a:ext>
             </a:extLst>
           </p:cNvPr>
@@ -2608,7 +2598,7 @@
     </p:spTree>
     <p:extLst>
       <p:ext uri="{BB962C8B-B14F-4D97-AF65-F5344CB8AC3E}">
-        <p14:creationId xmlns:p14="http://schemas.microsoft.com/office/powerpoint/2010/main" val="8899758"/>
+        <p14:creationId xmlns:p14="http://schemas.microsoft.com/office/powerpoint/2010/main" val="1347656116"/>
       </p:ext>
     </p:extLst>
   </p:cSld>
@@ -2639,7 +2629,7 @@
           <p:cNvPr id="15" name="title-4">
             <a:extLst xmlns:a="http://schemas.openxmlformats.org/drawingml/2006/main">
               <a:ext uri="{FF2B5EF4-FFF2-40B4-BE49-F238E27FC236}">
-                <a16:creationId xmlns:a16="http://schemas.microsoft.com/office/drawing/2014/main" id="{857AAFA3-B992-4FE4-B2F0-A0E17A2FA12B}"/>
+                <a16:creationId xmlns:a16="http://schemas.microsoft.com/office/drawing/2014/main" id="{ED507418-2AA0-455C-BE02-ACEEA1FEAB28}"/>
               </a:ext>
             </a:extLst>
           </p:cNvPr>
@@ -2697,7 +2687,7 @@
           <p:cNvPr id="2" name="number-4">
             <a:extLst xmlns:a="http://schemas.openxmlformats.org/drawingml/2006/main">
               <a:ext uri="{FF2B5EF4-FFF2-40B4-BE49-F238E27FC236}">
-                <a16:creationId xmlns:a16="http://schemas.microsoft.com/office/drawing/2014/main" id="{C54DED77-0075-45CE-93A6-E4A69A4F06DB}"/>
+                <a16:creationId xmlns:a16="http://schemas.microsoft.com/office/drawing/2014/main" id="{49603FF9-A0CB-4926-8F77-424AB69B6778}"/>
               </a:ext>
             </a:extLst>
           </p:cNvPr>
@@ -2755,7 +2745,7 @@
           <p:cNvPr id="3" name="cell-0-0">
             <a:extLst xmlns:a="http://schemas.openxmlformats.org/drawingml/2006/main">
               <a:ext uri="{FF2B5EF4-FFF2-40B4-BE49-F238E27FC236}">
-                <a16:creationId xmlns:a16="http://schemas.microsoft.com/office/drawing/2014/main" id="{7EF7B939-04D0-45B4-9400-E94C8E42418D}"/>
+                <a16:creationId xmlns:a16="http://schemas.microsoft.com/office/drawing/2014/main" id="{91BCB5EF-81A0-44ED-A8F5-7D7EDB71CCA9}"/>
               </a:ext>
             </a:extLst>
           </p:cNvPr>
@@ -2817,7 +2807,7 @@
           <p:cNvPr id="4" name="cell-0-1">
             <a:extLst xmlns:a="http://schemas.openxmlformats.org/drawingml/2006/main">
               <a:ext uri="{FF2B5EF4-FFF2-40B4-BE49-F238E27FC236}">
-                <a16:creationId xmlns:a16="http://schemas.microsoft.com/office/drawing/2014/main" id="{48888D28-6EDF-4695-A793-F1A2FFBCE129}"/>
+                <a16:creationId xmlns:a16="http://schemas.microsoft.com/office/drawing/2014/main" id="{856F75FD-0271-4301-8C23-B486F146FF7F}"/>
               </a:ext>
             </a:extLst>
           </p:cNvPr>
@@ -2879,7 +2869,7 @@
           <p:cNvPr id="5" name="cell-0-2">
             <a:extLst xmlns:a="http://schemas.openxmlformats.org/drawingml/2006/main">
               <a:ext uri="{FF2B5EF4-FFF2-40B4-BE49-F238E27FC236}">
-                <a16:creationId xmlns:a16="http://schemas.microsoft.com/office/drawing/2014/main" id="{830D8D29-2F62-4F05-900E-26FFDE70DC7B}"/>
+                <a16:creationId xmlns:a16="http://schemas.microsoft.com/office/drawing/2014/main" id="{B9D75F16-7DB1-491D-B0E2-0020F0F0E9B1}"/>
               </a:ext>
             </a:extLst>
           </p:cNvPr>
@@ -2941,7 +2931,7 @@
           <p:cNvPr id="6" name="cell-1-0">
             <a:extLst xmlns:a="http://schemas.openxmlformats.org/drawingml/2006/main">
               <a:ext uri="{FF2B5EF4-FFF2-40B4-BE49-F238E27FC236}">
-                <a16:creationId xmlns:a16="http://schemas.microsoft.com/office/drawing/2014/main" id="{4CA02137-902D-494C-8E1C-39E7DF684328}"/>
+                <a16:creationId xmlns:a16="http://schemas.microsoft.com/office/drawing/2014/main" id="{EF7E5DC3-7066-41C0-BE75-608652AB9009}"/>
               </a:ext>
             </a:extLst>
           </p:cNvPr>
@@ -3003,7 +2993,7 @@
           <p:cNvPr id="7" name="cell-1-1">
             <a:extLst xmlns:a="http://schemas.openxmlformats.org/drawingml/2006/main">
               <a:ext uri="{FF2B5EF4-FFF2-40B4-BE49-F238E27FC236}">
-                <a16:creationId xmlns:a16="http://schemas.microsoft.com/office/drawing/2014/main" id="{F000C98B-2B27-4C85-8402-C7A2B1FD5C7D}"/>
+                <a16:creationId xmlns:a16="http://schemas.microsoft.com/office/drawing/2014/main" id="{EB9408BB-262A-429A-B6C1-E72999F378D8}"/>
               </a:ext>
             </a:extLst>
           </p:cNvPr>
@@ -3065,7 +3055,7 @@
           <p:cNvPr id="8" name="cell-1-2">
             <a:extLst xmlns:a="http://schemas.openxmlformats.org/drawingml/2006/main">
               <a:ext uri="{FF2B5EF4-FFF2-40B4-BE49-F238E27FC236}">
-                <a16:creationId xmlns:a16="http://schemas.microsoft.com/office/drawing/2014/main" id="{31EE9D32-E43E-4C5F-BA4B-E1E37AB38F54}"/>
+                <a16:creationId xmlns:a16="http://schemas.microsoft.com/office/drawing/2014/main" id="{A0870F06-C46D-416C-B067-CD1251972054}"/>
               </a:ext>
             </a:extLst>
           </p:cNvPr>
@@ -3127,7 +3117,7 @@
           <p:cNvPr id="9" name="cell-2-0">
             <a:extLst xmlns:a="http://schemas.openxmlformats.org/drawingml/2006/main">
               <a:ext uri="{FF2B5EF4-FFF2-40B4-BE49-F238E27FC236}">
-                <a16:creationId xmlns:a16="http://schemas.microsoft.com/office/drawing/2014/main" id="{44EAD2EF-0535-4CE0-B924-A81E57B8DCFF}"/>
+                <a16:creationId xmlns:a16="http://schemas.microsoft.com/office/drawing/2014/main" id="{5DB5441D-0F7B-4307-8FF6-93B89E5ABF20}"/>
               </a:ext>
             </a:extLst>
           </p:cNvPr>
@@ -3189,7 +3179,7 @@
           <p:cNvPr id="10" name="cell-2-1">
             <a:extLst xmlns:a="http://schemas.openxmlformats.org/drawingml/2006/main">
               <a:ext uri="{FF2B5EF4-FFF2-40B4-BE49-F238E27FC236}">
-                <a16:creationId xmlns:a16="http://schemas.microsoft.com/office/drawing/2014/main" id="{B1F6EC6A-70B9-4951-8C1A-E02E526B41A4}"/>
+                <a16:creationId xmlns:a16="http://schemas.microsoft.com/office/drawing/2014/main" id="{0586ED83-68C0-4BED-BBFC-D4EBDBDF3B3C}"/>
               </a:ext>
             </a:extLst>
           </p:cNvPr>
@@ -3251,7 +3241,7 @@
           <p:cNvPr id="11" name="cell-2-2">
             <a:extLst xmlns:a="http://schemas.openxmlformats.org/drawingml/2006/main">
               <a:ext uri="{FF2B5EF4-FFF2-40B4-BE49-F238E27FC236}">
-                <a16:creationId xmlns:a16="http://schemas.microsoft.com/office/drawing/2014/main" id="{8DE64E36-4DEE-4D63-BD77-F77111E36382}"/>
+                <a16:creationId xmlns:a16="http://schemas.microsoft.com/office/drawing/2014/main" id="{94D028EF-60B2-4645-85BA-B72B9D0ACD70}"/>
               </a:ext>
             </a:extLst>
           </p:cNvPr>
@@ -3313,7 +3303,7 @@
           <p:cNvPr id="12" name="cell-3-0">
             <a:extLst xmlns:a="http://schemas.openxmlformats.org/drawingml/2006/main">
               <a:ext uri="{FF2B5EF4-FFF2-40B4-BE49-F238E27FC236}">
-                <a16:creationId xmlns:a16="http://schemas.microsoft.com/office/drawing/2014/main" id="{DA7C4B18-59B5-4E8C-83CC-AF4464C74D77}"/>
+                <a16:creationId xmlns:a16="http://schemas.microsoft.com/office/drawing/2014/main" id="{A5F2B26B-998E-40BD-9232-BFDCEB8AB595}"/>
               </a:ext>
             </a:extLst>
           </p:cNvPr>
@@ -3375,7 +3365,7 @@
           <p:cNvPr id="13" name="cell-3-1">
             <a:extLst xmlns:a="http://schemas.openxmlformats.org/drawingml/2006/main">
               <a:ext uri="{FF2B5EF4-FFF2-40B4-BE49-F238E27FC236}">
-                <a16:creationId xmlns:a16="http://schemas.microsoft.com/office/drawing/2014/main" id="{21C2F5A3-3E8B-4848-B71F-2EF77D2F8C53}"/>
+                <a16:creationId xmlns:a16="http://schemas.microsoft.com/office/drawing/2014/main" id="{9A51D8A8-B3D1-4AED-982B-3868C56CF5D8}"/>
               </a:ext>
             </a:extLst>
           </p:cNvPr>
@@ -3437,7 +3427,7 @@
           <p:cNvPr id="14" name="cell-3-2">
             <a:extLst xmlns:a="http://schemas.openxmlformats.org/drawingml/2006/main">
               <a:ext uri="{FF2B5EF4-FFF2-40B4-BE49-F238E27FC236}">
-                <a16:creationId xmlns:a16="http://schemas.microsoft.com/office/drawing/2014/main" id="{05A32A5C-C45A-4D73-B541-AC58FBD3734E}"/>
+                <a16:creationId xmlns:a16="http://schemas.microsoft.com/office/drawing/2014/main" id="{C55A9FB6-A923-496B-A360-5D1E750441AE}"/>
               </a:ext>
             </a:extLst>
           </p:cNvPr>
@@ -3497,7 +3487,7 @@
     </p:spTree>
     <p:extLst>
       <p:ext uri="{BB962C8B-B14F-4D97-AF65-F5344CB8AC3E}">
-        <p14:creationId xmlns:p14="http://schemas.microsoft.com/office/powerpoint/2010/main" val="1541263511"/>
+        <p14:creationId xmlns:p14="http://schemas.microsoft.com/office/powerpoint/2010/main" val="578636357"/>
       </p:ext>
     </p:extLst>
   </p:cSld>
@@ -3528,7 +3518,7 @@
           <p:cNvPr id="12" name="title-5">
             <a:extLst xmlns:a="http://schemas.openxmlformats.org/drawingml/2006/main">
               <a:ext uri="{FF2B5EF4-FFF2-40B4-BE49-F238E27FC236}">
-                <a16:creationId xmlns:a16="http://schemas.microsoft.com/office/drawing/2014/main" id="{7B7E10FE-6ADB-4119-8A06-E2A7477F6414}"/>
+                <a16:creationId xmlns:a16="http://schemas.microsoft.com/office/drawing/2014/main" id="{29582642-4682-4112-BA4E-FB71B546AE86}"/>
               </a:ext>
             </a:extLst>
           </p:cNvPr>
@@ -3586,7 +3576,7 @@
           <p:cNvPr id="2" name="number-5">
             <a:extLst xmlns:a="http://schemas.openxmlformats.org/drawingml/2006/main">
               <a:ext uri="{FF2B5EF4-FFF2-40B4-BE49-F238E27FC236}">
-                <a16:creationId xmlns:a16="http://schemas.microsoft.com/office/drawing/2014/main" id="{E9197F2A-7D1E-495B-B1AD-6478ECDD1491}"/>
+                <a16:creationId xmlns:a16="http://schemas.microsoft.com/office/drawing/2014/main" id="{F1C29EA5-6B19-4624-8B63-2BCB7447A90E}"/>
               </a:ext>
             </a:extLst>
           </p:cNvPr>
@@ -3644,7 +3634,7 @@
           <p:cNvPr id="3" name="stat-panel-0">
             <a:extLst xmlns:a="http://schemas.openxmlformats.org/drawingml/2006/main">
               <a:ext uri="{FF2B5EF4-FFF2-40B4-BE49-F238E27FC236}">
-                <a16:creationId xmlns:a16="http://schemas.microsoft.com/office/drawing/2014/main" id="{E42AC470-7629-4864-97BF-C957CAA8E922}"/>
+                <a16:creationId xmlns:a16="http://schemas.microsoft.com/office/drawing/2014/main" id="{B51F57D1-EC9C-472D-9652-8511485CA7FF}"/>
               </a:ext>
             </a:extLst>
           </p:cNvPr>
@@ -3658,10 +3648,8 @@
             <a:off x="495300" y="2381250"/>
             <a:ext cx="3562350" cy="2952750"/>
           </a:xfrm>
-          <a:prstGeom xmlns:a="http://schemas.openxmlformats.org/drawingml/2006/main" prst="roundRect">
-            <a:avLst>
-              <a:gd name="adj" fmla="val 2581"/>
-            </a:avLst>
+          <a:prstGeom xmlns:a="http://schemas.openxmlformats.org/drawingml/2006/main" prst="rect">
+            <a:avLst/>
           </a:prstGeom>
           <a:solidFill xmlns:a="http://schemas.openxmlformats.org/drawingml/2006/main">
             <a:srgbClr val="EDEDED"/>
@@ -3677,7 +3665,7 @@
           <p:cNvPr id="4" name="stat-0">
             <a:extLst xmlns:a="http://schemas.openxmlformats.org/drawingml/2006/main">
               <a:ext uri="{FF2B5EF4-FFF2-40B4-BE49-F238E27FC236}">
-                <a16:creationId xmlns:a16="http://schemas.microsoft.com/office/drawing/2014/main" id="{82DE7D22-7F2C-4307-886F-7F48A6797998}"/>
+                <a16:creationId xmlns:a16="http://schemas.microsoft.com/office/drawing/2014/main" id="{43D7F894-B368-4DC3-8377-5FCB4F4B530A}"/>
               </a:ext>
             </a:extLst>
           </p:cNvPr>
@@ -3735,7 +3723,7 @@
           <p:cNvPr id="5" name="stat-caption-0">
             <a:extLst xmlns:a="http://schemas.openxmlformats.org/drawingml/2006/main">
               <a:ext uri="{FF2B5EF4-FFF2-40B4-BE49-F238E27FC236}">
-                <a16:creationId xmlns:a16="http://schemas.microsoft.com/office/drawing/2014/main" id="{CC51C689-9457-4E23-BA34-71586F85801D}"/>
+                <a16:creationId xmlns:a16="http://schemas.microsoft.com/office/drawing/2014/main" id="{C4BF3823-8EF8-4EC9-B928-A40442EE038D}"/>
               </a:ext>
             </a:extLst>
           </p:cNvPr>
@@ -3793,7 +3781,7 @@
           <p:cNvPr id="6" name="stat-panel-1">
             <a:extLst xmlns:a="http://schemas.openxmlformats.org/drawingml/2006/main">
               <a:ext uri="{FF2B5EF4-FFF2-40B4-BE49-F238E27FC236}">
-                <a16:creationId xmlns:a16="http://schemas.microsoft.com/office/drawing/2014/main" id="{89F76B30-44FB-4910-B25E-51603052962F}"/>
+                <a16:creationId xmlns:a16="http://schemas.microsoft.com/office/drawing/2014/main" id="{8266C388-4585-4DE9-AE3A-D64F6ABFE936}"/>
               </a:ext>
             </a:extLst>
           </p:cNvPr>
@@ -3807,10 +3795,8 @@
             <a:off x="4419600" y="2381250"/>
             <a:ext cx="3562350" cy="2952750"/>
           </a:xfrm>
-          <a:prstGeom xmlns:a="http://schemas.openxmlformats.org/drawingml/2006/main" prst="roundRect">
-            <a:avLst>
-              <a:gd name="adj" fmla="val 2581"/>
-            </a:avLst>
+          <a:prstGeom xmlns:a="http://schemas.openxmlformats.org/drawingml/2006/main" prst="rect">
+            <a:avLst/>
           </a:prstGeom>
           <a:solidFill xmlns:a="http://schemas.openxmlformats.org/drawingml/2006/main">
             <a:srgbClr val="EDEDED"/>
@@ -3826,7 +3812,7 @@
           <p:cNvPr id="7" name="stat-1">
             <a:extLst xmlns:a="http://schemas.openxmlformats.org/drawingml/2006/main">
               <a:ext uri="{FF2B5EF4-FFF2-40B4-BE49-F238E27FC236}">
-                <a16:creationId xmlns:a16="http://schemas.microsoft.com/office/drawing/2014/main" id="{D17ABC0F-6F35-44ED-A3FB-8284BDA824A4}"/>
+                <a16:creationId xmlns:a16="http://schemas.microsoft.com/office/drawing/2014/main" id="{BB2D846D-B77B-4706-9B6E-EABF852172FB}"/>
               </a:ext>
             </a:extLst>
           </p:cNvPr>
@@ -3884,7 +3870,7 @@
           <p:cNvPr id="8" name="stat-caption-1">
             <a:extLst xmlns:a="http://schemas.openxmlformats.org/drawingml/2006/main">
               <a:ext uri="{FF2B5EF4-FFF2-40B4-BE49-F238E27FC236}">
-                <a16:creationId xmlns:a16="http://schemas.microsoft.com/office/drawing/2014/main" id="{3654CDAF-2C14-4B7C-936F-597A0F422D7C}"/>
+                <a16:creationId xmlns:a16="http://schemas.microsoft.com/office/drawing/2014/main" id="{0184326D-F95E-486A-A7E3-5AE48507E2B7}"/>
               </a:ext>
             </a:extLst>
           </p:cNvPr>
@@ -3942,7 +3928,7 @@
           <p:cNvPr id="9" name="stat-panel-2">
             <a:extLst xmlns:a="http://schemas.openxmlformats.org/drawingml/2006/main">
               <a:ext uri="{FF2B5EF4-FFF2-40B4-BE49-F238E27FC236}">
-                <a16:creationId xmlns:a16="http://schemas.microsoft.com/office/drawing/2014/main" id="{05F7855B-9AFE-440D-98CB-E51469513707}"/>
+                <a16:creationId xmlns:a16="http://schemas.microsoft.com/office/drawing/2014/main" id="{53725E6C-B959-4D52-8188-0BCC9E51057D}"/>
               </a:ext>
             </a:extLst>
           </p:cNvPr>
@@ -3956,10 +3942,8 @@
             <a:off x="8343900" y="2381250"/>
             <a:ext cx="3562350" cy="2952750"/>
           </a:xfrm>
-          <a:prstGeom xmlns:a="http://schemas.openxmlformats.org/drawingml/2006/main" prst="roundRect">
-            <a:avLst>
-              <a:gd name="adj" fmla="val 2581"/>
-            </a:avLst>
+          <a:prstGeom xmlns:a="http://schemas.openxmlformats.org/drawingml/2006/main" prst="rect">
+            <a:avLst/>
           </a:prstGeom>
           <a:solidFill xmlns:a="http://schemas.openxmlformats.org/drawingml/2006/main">
             <a:srgbClr val="EDEDED"/>
@@ -3975,7 +3959,7 @@
           <p:cNvPr id="10" name="stat-2">
             <a:extLst xmlns:a="http://schemas.openxmlformats.org/drawingml/2006/main">
               <a:ext uri="{FF2B5EF4-FFF2-40B4-BE49-F238E27FC236}">
-                <a16:creationId xmlns:a16="http://schemas.microsoft.com/office/drawing/2014/main" id="{A0DCBDAD-DAE4-4101-BCB3-D81FDE22841D}"/>
+                <a16:creationId xmlns:a16="http://schemas.microsoft.com/office/drawing/2014/main" id="{33AB42A1-2F12-46B6-99FA-49F1AF7B1AC6}"/>
               </a:ext>
             </a:extLst>
           </p:cNvPr>
@@ -4033,7 +4017,7 @@
           <p:cNvPr id="11" name="stat-caption-2">
             <a:extLst xmlns:a="http://schemas.openxmlformats.org/drawingml/2006/main">
               <a:ext uri="{FF2B5EF4-FFF2-40B4-BE49-F238E27FC236}">
-                <a16:creationId xmlns:a16="http://schemas.microsoft.com/office/drawing/2014/main" id="{BD688AE6-E274-4326-A2E2-ABCD88B36434}"/>
+                <a16:creationId xmlns:a16="http://schemas.microsoft.com/office/drawing/2014/main" id="{2321BD0A-D80E-4453-81FA-B20752715E7C}"/>
               </a:ext>
             </a:extLst>
           </p:cNvPr>
@@ -4089,7 +4073,7 @@
     </p:spTree>
     <p:extLst>
       <p:ext uri="{BB962C8B-B14F-4D97-AF65-F5344CB8AC3E}">
-        <p14:creationId xmlns:p14="http://schemas.microsoft.com/office/powerpoint/2010/main" val="759418347"/>
+        <p14:creationId xmlns:p14="http://schemas.microsoft.com/office/powerpoint/2010/main" val="925281673"/>
       </p:ext>
     </p:extLst>
   </p:cSld>
@@ -4120,7 +4104,7 @@
           <p:cNvPr id="10" name="title-6">
             <a:extLst xmlns:a="http://schemas.openxmlformats.org/drawingml/2006/main">
               <a:ext uri="{FF2B5EF4-FFF2-40B4-BE49-F238E27FC236}">
-                <a16:creationId xmlns:a16="http://schemas.microsoft.com/office/drawing/2014/main" id="{4815A47E-85C8-4F78-BAF5-244B7DFC21BE}"/>
+                <a16:creationId xmlns:a16="http://schemas.microsoft.com/office/drawing/2014/main" id="{59E0526F-FDC7-4B72-BE1E-54F7BE74903B}"/>
               </a:ext>
             </a:extLst>
           </p:cNvPr>
@@ -4178,7 +4162,7 @@
           <p:cNvPr id="2" name="number-6">
             <a:extLst xmlns:a="http://schemas.openxmlformats.org/drawingml/2006/main">
               <a:ext uri="{FF2B5EF4-FFF2-40B4-BE49-F238E27FC236}">
-                <a16:creationId xmlns:a16="http://schemas.microsoft.com/office/drawing/2014/main" id="{66F6F678-5BCB-44A1-BF0A-DD2CE23BD600}"/>
+                <a16:creationId xmlns:a16="http://schemas.microsoft.com/office/drawing/2014/main" id="{11E3A510-B53D-4FF7-8ABB-0FCFC8CBEB8F}"/>
               </a:ext>
             </a:extLst>
           </p:cNvPr>
@@ -4236,7 +4220,7 @@
           <p:cNvPr id="3" name="step-num-0">
             <a:extLst xmlns:a="http://schemas.openxmlformats.org/drawingml/2006/main">
               <a:ext uri="{FF2B5EF4-FFF2-40B4-BE49-F238E27FC236}">
-                <a16:creationId xmlns:a16="http://schemas.microsoft.com/office/drawing/2014/main" id="{003B5F79-5C4F-406E-86BC-05137C1FA5C2}"/>
+                <a16:creationId xmlns:a16="http://schemas.microsoft.com/office/drawing/2014/main" id="{7CD0E520-C475-49AE-9B94-B90625686450}"/>
               </a:ext>
             </a:extLst>
           </p:cNvPr>
@@ -4250,10 +4234,8 @@
             <a:off x="571500" y="1619250"/>
             <a:ext cx="647700" cy="647700"/>
           </a:xfrm>
-          <a:prstGeom xmlns:a="http://schemas.openxmlformats.org/drawingml/2006/main" prst="roundRect">
-            <a:avLst>
-              <a:gd name="adj" fmla="val 11765"/>
-            </a:avLst>
+          <a:prstGeom xmlns:a="http://schemas.openxmlformats.org/drawingml/2006/main" prst="rect">
+            <a:avLst/>
           </a:prstGeom>
           <a:solidFill xmlns:a="http://schemas.openxmlformats.org/drawingml/2006/main">
             <a:srgbClr val="D0EDFA"/>
@@ -4298,7 +4280,7 @@
           <p:cNvPr id="4" name="step-0">
             <a:extLst xmlns:a="http://schemas.openxmlformats.org/drawingml/2006/main">
               <a:ext uri="{FF2B5EF4-FFF2-40B4-BE49-F238E27FC236}">
-                <a16:creationId xmlns:a16="http://schemas.microsoft.com/office/drawing/2014/main" id="{CC83BF20-3B94-4B56-911B-D3FBD6636146}"/>
+                <a16:creationId xmlns:a16="http://schemas.microsoft.com/office/drawing/2014/main" id="{CB31C8A2-5CDC-470A-99FB-130B16B5FC4C}"/>
               </a:ext>
             </a:extLst>
           </p:cNvPr>
@@ -4356,7 +4338,7 @@
           <p:cNvPr id="5" name="step-num-1">
             <a:extLst xmlns:a="http://schemas.openxmlformats.org/drawingml/2006/main">
               <a:ext uri="{FF2B5EF4-FFF2-40B4-BE49-F238E27FC236}">
-                <a16:creationId xmlns:a16="http://schemas.microsoft.com/office/drawing/2014/main" id="{352164A7-8D07-47D2-919B-12AAC493EB48}"/>
+                <a16:creationId xmlns:a16="http://schemas.microsoft.com/office/drawing/2014/main" id="{5EBBD613-EAFE-459E-AE47-8B3181230D87}"/>
               </a:ext>
             </a:extLst>
           </p:cNvPr>
@@ -4370,10 +4352,8 @@
             <a:off x="571500" y="2857500"/>
             <a:ext cx="647700" cy="647700"/>
           </a:xfrm>
-          <a:prstGeom xmlns:a="http://schemas.openxmlformats.org/drawingml/2006/main" prst="roundRect">
-            <a:avLst>
-              <a:gd name="adj" fmla="val 11765"/>
-            </a:avLst>
+          <a:prstGeom xmlns:a="http://schemas.openxmlformats.org/drawingml/2006/main" prst="rect">
+            <a:avLst/>
           </a:prstGeom>
           <a:solidFill xmlns:a="http://schemas.openxmlformats.org/drawingml/2006/main">
             <a:srgbClr val="D0EDFA"/>
@@ -4418,7 +4398,7 @@
           <p:cNvPr id="6" name="step-1">
             <a:extLst xmlns:a="http://schemas.openxmlformats.org/drawingml/2006/main">
               <a:ext uri="{FF2B5EF4-FFF2-40B4-BE49-F238E27FC236}">
-                <a16:creationId xmlns:a16="http://schemas.microsoft.com/office/drawing/2014/main" id="{01805E46-5BEC-41EA-8751-28360CB499E4}"/>
+                <a16:creationId xmlns:a16="http://schemas.microsoft.com/office/drawing/2014/main" id="{F7694CA0-F53C-4575-8DEA-E731607C2517}"/>
               </a:ext>
             </a:extLst>
           </p:cNvPr>
@@ -4476,7 +4456,7 @@
           <p:cNvPr id="7" name="step-num-2">
             <a:extLst xmlns:a="http://schemas.openxmlformats.org/drawingml/2006/main">
               <a:ext uri="{FF2B5EF4-FFF2-40B4-BE49-F238E27FC236}">
-                <a16:creationId xmlns:a16="http://schemas.microsoft.com/office/drawing/2014/main" id="{CCE1E0E2-5280-468E-9CEF-0DB574E757A1}"/>
+                <a16:creationId xmlns:a16="http://schemas.microsoft.com/office/drawing/2014/main" id="{DC047474-8D01-4B24-9F05-EEFD3AED2D71}"/>
               </a:ext>
             </a:extLst>
           </p:cNvPr>
@@ -4490,10 +4470,8 @@
             <a:off x="571500" y="4095750"/>
             <a:ext cx="647700" cy="647700"/>
           </a:xfrm>
-          <a:prstGeom xmlns:a="http://schemas.openxmlformats.org/drawingml/2006/main" prst="roundRect">
-            <a:avLst>
-              <a:gd name="adj" fmla="val 11765"/>
-            </a:avLst>
+          <a:prstGeom xmlns:a="http://schemas.openxmlformats.org/drawingml/2006/main" prst="rect">
+            <a:avLst/>
           </a:prstGeom>
           <a:solidFill xmlns:a="http://schemas.openxmlformats.org/drawingml/2006/main">
             <a:srgbClr val="D0EDFA"/>
@@ -4538,7 +4516,7 @@
           <p:cNvPr id="8" name="step-2">
             <a:extLst xmlns:a="http://schemas.openxmlformats.org/drawingml/2006/main">
               <a:ext uri="{FF2B5EF4-FFF2-40B4-BE49-F238E27FC236}">
-                <a16:creationId xmlns:a16="http://schemas.microsoft.com/office/drawing/2014/main" id="{443F888B-1373-4409-97F4-A8D3E451D1D8}"/>
+                <a16:creationId xmlns:a16="http://schemas.microsoft.com/office/drawing/2014/main" id="{D37EE0D6-32B9-4CCC-B013-C7434950FD40}"/>
               </a:ext>
             </a:extLst>
           </p:cNvPr>
@@ -4596,7 +4574,7 @@
           <p:cNvPr id="9" name="result-status">
             <a:extLst xmlns:a="http://schemas.openxmlformats.org/drawingml/2006/main">
               <a:ext uri="{FF2B5EF4-FFF2-40B4-BE49-F238E27FC236}">
-                <a16:creationId xmlns:a16="http://schemas.microsoft.com/office/drawing/2014/main" id="{45BB9CD1-03A7-435F-BC6D-F755187A97EB}"/>
+                <a16:creationId xmlns:a16="http://schemas.microsoft.com/office/drawing/2014/main" id="{18F89460-06A2-459B-89AD-FD94886E6F6C}"/>
               </a:ext>
             </a:extLst>
           </p:cNvPr>
@@ -4652,7 +4630,7 @@
     </p:spTree>
     <p:extLst>
       <p:ext uri="{BB962C8B-B14F-4D97-AF65-F5344CB8AC3E}">
-        <p14:creationId xmlns:p14="http://schemas.microsoft.com/office/powerpoint/2010/main" val="398006722"/>
+        <p14:creationId xmlns:p14="http://schemas.microsoft.com/office/powerpoint/2010/main" val="1945722316"/>
       </p:ext>
     </p:extLst>
   </p:cSld>

</xml_diff>

<commit_message>
test: harden document format release QA
</commit_message>
<xml_diff>
--- a/tests/formats/output/career-entry-12-week-roadmap/brief.pptx
+++ b/tests/formats/output/career-entry-12-week-roadmap/brief.pptx
@@ -2,18 +2,18 @@
 <file path=ppt/presentation.xml><?xml version="1.0" encoding="utf-8"?>
 <p:presentation xmlns:p="http://schemas.openxmlformats.org/presentationml/2006/main">
   <p:sldMasterIdLst>
-    <p:sldMasterId xmlns:r="http://schemas.openxmlformats.org/officeDocument/2006/relationships" id="2147483648" r:id="Rdd4d2a92b56547c4"/>
+    <p:sldMasterId xmlns:r="http://schemas.openxmlformats.org/officeDocument/2006/relationships" id="2147483648" r:id="R1e5a64b0d9804264"/>
   </p:sldMasterIdLst>
   <p:notesMasterIdLst>
-    <p:notesMasterId xmlns:r="http://schemas.openxmlformats.org/officeDocument/2006/relationships" r:id="Rc8daef980f2f4d56"/>
+    <p:notesMasterId xmlns:r="http://schemas.openxmlformats.org/officeDocument/2006/relationships" r:id="Rc53bcc8a7fc74b56"/>
   </p:notesMasterIdLst>
   <p:sldIdLst>
-    <p:sldId xmlns:r="http://schemas.openxmlformats.org/officeDocument/2006/relationships" id="256" r:id="Rf6382d2a775a4ef7"/>
-    <p:sldId xmlns:r="http://schemas.openxmlformats.org/officeDocument/2006/relationships" id="257" r:id="Re0e45f106fa94b56"/>
-    <p:sldId xmlns:r="http://schemas.openxmlformats.org/officeDocument/2006/relationships" id="258" r:id="Rcce85fe153144e89"/>
-    <p:sldId xmlns:r="http://schemas.openxmlformats.org/officeDocument/2006/relationships" id="259" r:id="Rf092ac4782ad4965"/>
-    <p:sldId xmlns:r="http://schemas.openxmlformats.org/officeDocument/2006/relationships" id="260" r:id="Rb3e576730eb7473d"/>
-    <p:sldId xmlns:r="http://schemas.openxmlformats.org/officeDocument/2006/relationships" id="261" r:id="R2c3cdc6f57084467"/>
+    <p:sldId xmlns:r="http://schemas.openxmlformats.org/officeDocument/2006/relationships" id="256" r:id="Rd762b0922e4043f5"/>
+    <p:sldId xmlns:r="http://schemas.openxmlformats.org/officeDocument/2006/relationships" id="257" r:id="Rc42f579c405140a0"/>
+    <p:sldId xmlns:r="http://schemas.openxmlformats.org/officeDocument/2006/relationships" id="258" r:id="R8aed27db57dd4d43"/>
+    <p:sldId xmlns:r="http://schemas.openxmlformats.org/officeDocument/2006/relationships" id="259" r:id="R86b121e052a3429d"/>
+    <p:sldId xmlns:r="http://schemas.openxmlformats.org/officeDocument/2006/relationships" id="260" r:id="Rfcd99ede23b441ed"/>
+    <p:sldId xmlns:r="http://schemas.openxmlformats.org/officeDocument/2006/relationships" id="261" r:id="R4c26575ff6a34888"/>
   </p:sldIdLst>
   <p:sldSz cx="12192000" cy="6858000"/>
   <p:notesSz cx="6858000" cy="9144000"/>
@@ -900,7 +900,7 @@
   </p:cSld>
   <p:clrMap bg1="lt1" tx1="dk1" bg2="lt2" tx2="dk2" accent1="accent1" accent2="accent2" accent3="accent3" accent4="accent4" accent5="accent5" accent6="accent6" hlink="hlink" folHlink="folHlink"/>
   <p:sldLayoutIdLst>
-    <p:sldLayoutId xmlns:r="http://schemas.openxmlformats.org/officeDocument/2006/relationships" id="2147483649" r:id="R5ba5730672c74d80"/>
+    <p:sldLayoutId xmlns:r="http://schemas.openxmlformats.org/officeDocument/2006/relationships" id="2147483649" r:id="Rc0248f2a0c554340"/>
   </p:sldLayoutIdLst>
   <p:txStyles>
     <p:titleStyle>
@@ -1451,7 +1451,7 @@
           <p:cNvPr id="7" name="cover-kicker">
             <a:extLst xmlns:a="http://schemas.openxmlformats.org/drawingml/2006/main">
               <a:ext uri="{FF2B5EF4-FFF2-40B4-BE49-F238E27FC236}">
-                <a16:creationId xmlns:a16="http://schemas.microsoft.com/office/drawing/2014/main" id="{FCE9152B-EB0A-4896-973C-750E49462115}"/>
+                <a16:creationId xmlns:a16="http://schemas.microsoft.com/office/drawing/2014/main" id="{CDCA994D-D044-410B-B1E1-DD84347E1D48}"/>
               </a:ext>
             </a:extLst>
           </p:cNvPr>
@@ -1509,7 +1509,7 @@
           <p:cNvPr id="2" name="cover-title">
             <a:extLst xmlns:a="http://schemas.openxmlformats.org/drawingml/2006/main">
               <a:ext uri="{FF2B5EF4-FFF2-40B4-BE49-F238E27FC236}">
-                <a16:creationId xmlns:a16="http://schemas.microsoft.com/office/drawing/2014/main" id="{915FCC00-BB1C-48EF-83D4-2C0794E04A3A}"/>
+                <a16:creationId xmlns:a16="http://schemas.microsoft.com/office/drawing/2014/main" id="{1A28FDD8-BF72-42CD-A7BF-1FC8BC371827}"/>
               </a:ext>
             </a:extLst>
           </p:cNvPr>
@@ -1590,7 +1590,7 @@
           <p:cNvPr id="3" name="cover-subtitle">
             <a:extLst xmlns:a="http://schemas.openxmlformats.org/drawingml/2006/main">
               <a:ext uri="{FF2B5EF4-FFF2-40B4-BE49-F238E27FC236}">
-                <a16:creationId xmlns:a16="http://schemas.microsoft.com/office/drawing/2014/main" id="{B530B0DA-7F01-4E0C-9EA6-48426B087D78}"/>
+                <a16:creationId xmlns:a16="http://schemas.microsoft.com/office/drawing/2014/main" id="{838E68D1-A210-404C-BF04-08C855724693}"/>
               </a:ext>
             </a:extLst>
           </p:cNvPr>
@@ -1648,7 +1648,7 @@
           <p:cNvPr id="4" name="cover-panel">
             <a:extLst xmlns:a="http://schemas.openxmlformats.org/drawingml/2006/main">
               <a:ext uri="{FF2B5EF4-FFF2-40B4-BE49-F238E27FC236}">
-                <a16:creationId xmlns:a16="http://schemas.microsoft.com/office/drawing/2014/main" id="{99CE7C0C-360B-4A80-BEFF-B5D6E597A1BD}"/>
+                <a16:creationId xmlns:a16="http://schemas.microsoft.com/office/drawing/2014/main" id="{0BCA5AFB-2CE2-4B11-BA10-D8D9872E589B}"/>
               </a:ext>
             </a:extLst>
           </p:cNvPr>
@@ -1681,7 +1681,7 @@
           <p:cNvPr id="5" name="cover-mark">
             <a:extLst xmlns:a="http://schemas.openxmlformats.org/drawingml/2006/main">
               <a:ext uri="{FF2B5EF4-FFF2-40B4-BE49-F238E27FC236}">
-                <a16:creationId xmlns:a16="http://schemas.microsoft.com/office/drawing/2014/main" id="{F00472AD-560D-482E-847B-D832591AE7AB}"/>
+                <a16:creationId xmlns:a16="http://schemas.microsoft.com/office/drawing/2014/main" id="{7E870C03-6473-4757-BFEF-2B6BBDBCDD29}"/>
               </a:ext>
             </a:extLst>
           </p:cNvPr>
@@ -1739,7 +1739,7 @@
           <p:cNvPr id="6" name="cover-caption">
             <a:extLst xmlns:a="http://schemas.openxmlformats.org/drawingml/2006/main">
               <a:ext uri="{FF2B5EF4-FFF2-40B4-BE49-F238E27FC236}">
-                <a16:creationId xmlns:a16="http://schemas.microsoft.com/office/drawing/2014/main" id="{2A128BEF-D6CF-4351-ADD9-54797E9DAF83}"/>
+                <a16:creationId xmlns:a16="http://schemas.microsoft.com/office/drawing/2014/main" id="{751A76AA-1A17-46BD-96C2-68B1DEE13126}"/>
               </a:ext>
             </a:extLst>
           </p:cNvPr>
@@ -1795,7 +1795,7 @@
     </p:spTree>
     <p:extLst>
       <p:ext uri="{BB962C8B-B14F-4D97-AF65-F5344CB8AC3E}">
-        <p14:creationId xmlns:p14="http://schemas.microsoft.com/office/powerpoint/2010/main" val="1518344835"/>
+        <p14:creationId xmlns:p14="http://schemas.microsoft.com/office/powerpoint/2010/main" val="2102220878"/>
       </p:ext>
     </p:extLst>
   </p:cSld>
@@ -1826,7 +1826,7 @@
           <p:cNvPr id="7" name="title-2">
             <a:extLst xmlns:a="http://schemas.openxmlformats.org/drawingml/2006/main">
               <a:ext uri="{FF2B5EF4-FFF2-40B4-BE49-F238E27FC236}">
-                <a16:creationId xmlns:a16="http://schemas.microsoft.com/office/drawing/2014/main" id="{F52121A7-D5F5-4CA6-950A-7324A9B38167}"/>
+                <a16:creationId xmlns:a16="http://schemas.microsoft.com/office/drawing/2014/main" id="{0BAD957D-65FF-4DF0-B8E3-89F3E44745B0}"/>
               </a:ext>
             </a:extLst>
           </p:cNvPr>
@@ -1884,7 +1884,7 @@
           <p:cNvPr id="2" name="number-2">
             <a:extLst xmlns:a="http://schemas.openxmlformats.org/drawingml/2006/main">
               <a:ext uri="{FF2B5EF4-FFF2-40B4-BE49-F238E27FC236}">
-                <a16:creationId xmlns:a16="http://schemas.microsoft.com/office/drawing/2014/main" id="{2E57B199-404A-405D-AF14-0AC3BA192BA0}"/>
+                <a16:creationId xmlns:a16="http://schemas.microsoft.com/office/drawing/2014/main" id="{2BC16523-798B-4247-8EBF-9C84626E2FFF}"/>
               </a:ext>
             </a:extLst>
           </p:cNvPr>
@@ -1942,7 +1942,7 @@
           <p:cNvPr id="3" name="half-body">
             <a:extLst xmlns:a="http://schemas.openxmlformats.org/drawingml/2006/main">
               <a:ext uri="{FF2B5EF4-FFF2-40B4-BE49-F238E27FC236}">
-                <a16:creationId xmlns:a16="http://schemas.microsoft.com/office/drawing/2014/main" id="{475B5AF3-E713-47F6-867C-59A00FA2C9D4}"/>
+                <a16:creationId xmlns:a16="http://schemas.microsoft.com/office/drawing/2014/main" id="{A01F173B-BC0B-4588-A085-962344218C39}"/>
               </a:ext>
             </a:extLst>
           </p:cNvPr>
@@ -1990,7 +1990,76 @@
                 <a:ea typeface="D2Coding"/>
                 <a:cs typeface="D2Coding"/>
               </a:rPr>
-              <a:t>시스템 디자인은 규칙·예외·데이터·플레이테스트 증거가 필요하다. 콘텐츠 디자인은 반복 구조·페이싱·제작 핸드오프가 필요하다.</a:t>
+              <a:t>시스템 디자인은 규칙·예외·데이터와</a:t>
+            </a:r>
+          </a:p>
+          <a:p xmlns:a="http://schemas.openxmlformats.org/drawingml/2006/main">
+            <a:pPr algn="l">
+              <a:defRPr sz="1875" b="0">
+                <a:solidFill>
+                  <a:srgbClr val="0F172A"/>
+                </a:solidFill>
+                <a:latin typeface="D2Coding"/>
+                <a:ea typeface="D2Coding"/>
+                <a:cs typeface="D2Coding"/>
+              </a:defRPr>
+            </a:pPr>
+            <a:r>
+              <a:rPr sz="1875" b="0">
+                <a:solidFill>
+                  <a:srgbClr val="0F172A"/>
+                </a:solidFill>
+                <a:latin typeface="D2Coding"/>
+                <a:ea typeface="D2Coding"/>
+                <a:cs typeface="D2Coding"/>
+              </a:rPr>
+              <a:t>플레이테스트 증거가 필요하다.</a:t>
+            </a:r>
+          </a:p>
+          <a:p xmlns:a="http://schemas.openxmlformats.org/drawingml/2006/main">
+            <a:pPr algn="l">
+              <a:defRPr sz="1875" b="0">
+                <a:solidFill>
+                  <a:srgbClr val="0F172A"/>
+                </a:solidFill>
+                <a:latin typeface="D2Coding"/>
+                <a:ea typeface="D2Coding"/>
+                <a:cs typeface="D2Coding"/>
+              </a:defRPr>
+            </a:pPr>
+            <a:r>
+              <a:rPr sz="1875" b="0">
+                <a:solidFill>
+                  <a:srgbClr val="0F172A"/>
+                </a:solidFill>
+                <a:latin typeface="D2Coding"/>
+                <a:ea typeface="D2Coding"/>
+                <a:cs typeface="D2Coding"/>
+              </a:rPr>
+              <a:t>콘텐츠 디자인은 반복 구조·페이싱과</a:t>
+            </a:r>
+          </a:p>
+          <a:p xmlns:a="http://schemas.openxmlformats.org/drawingml/2006/main">
+            <a:pPr algn="l">
+              <a:defRPr sz="1875" b="0">
+                <a:solidFill>
+                  <a:srgbClr val="0F172A"/>
+                </a:solidFill>
+                <a:latin typeface="D2Coding"/>
+                <a:ea typeface="D2Coding"/>
+                <a:cs typeface="D2Coding"/>
+              </a:defRPr>
+            </a:pPr>
+            <a:r>
+              <a:rPr sz="1875" b="0">
+                <a:solidFill>
+                  <a:srgbClr val="0F172A"/>
+                </a:solidFill>
+                <a:latin typeface="D2Coding"/>
+                <a:ea typeface="D2Coding"/>
+                <a:cs typeface="D2Coding"/>
+              </a:rPr>
+              <a:t>제작 핸드오프가 필요하다.</a:t>
             </a:r>
           </a:p>
         </p:txBody>
@@ -2000,7 +2069,7 @@
           <p:cNvPr id="4" name="half-visual">
             <a:extLst xmlns:a="http://schemas.openxmlformats.org/drawingml/2006/main">
               <a:ext uri="{FF2B5EF4-FFF2-40B4-BE49-F238E27FC236}">
-                <a16:creationId xmlns:a16="http://schemas.microsoft.com/office/drawing/2014/main" id="{8AA94C4D-4238-4551-85DA-5A6D16DF4ABF}"/>
+                <a16:creationId xmlns:a16="http://schemas.microsoft.com/office/drawing/2014/main" id="{F68231D5-A44A-4579-A9C1-B16DE36BB70A}"/>
               </a:ext>
             </a:extLst>
           </p:cNvPr>
@@ -2033,7 +2102,7 @@
           <p:cNvPr id="5" name="half-signal">
             <a:extLst xmlns:a="http://schemas.openxmlformats.org/drawingml/2006/main">
               <a:ext uri="{FF2B5EF4-FFF2-40B4-BE49-F238E27FC236}">
-                <a16:creationId xmlns:a16="http://schemas.microsoft.com/office/drawing/2014/main" id="{BEFE9C8D-4683-4A53-993D-87E489B80183}"/>
+                <a16:creationId xmlns:a16="http://schemas.microsoft.com/office/drawing/2014/main" id="{3DB4BF3E-B80F-4963-978E-850F51A5EC02}"/>
               </a:ext>
             </a:extLst>
           </p:cNvPr>
@@ -2091,7 +2160,7 @@
           <p:cNvPr id="6" name="half-caption">
             <a:extLst xmlns:a="http://schemas.openxmlformats.org/drawingml/2006/main">
               <a:ext uri="{FF2B5EF4-FFF2-40B4-BE49-F238E27FC236}">
-                <a16:creationId xmlns:a16="http://schemas.microsoft.com/office/drawing/2014/main" id="{0241D644-0A69-4168-B1DD-AB3A53D40B16}"/>
+                <a16:creationId xmlns:a16="http://schemas.microsoft.com/office/drawing/2014/main" id="{CDD52452-9CB5-4EB6-B760-A6EDBFC0A01D}"/>
               </a:ext>
             </a:extLst>
           </p:cNvPr>
@@ -2147,7 +2216,7 @@
     </p:spTree>
     <p:extLst>
       <p:ext uri="{BB962C8B-B14F-4D97-AF65-F5344CB8AC3E}">
-        <p14:creationId xmlns:p14="http://schemas.microsoft.com/office/powerpoint/2010/main" val="1351043623"/>
+        <p14:creationId xmlns:p14="http://schemas.microsoft.com/office/powerpoint/2010/main" val="1393789165"/>
       </p:ext>
     </p:extLst>
   </p:cSld>
@@ -2178,7 +2247,7 @@
           <p:cNvPr id="9" name="title-3">
             <a:extLst xmlns:a="http://schemas.openxmlformats.org/drawingml/2006/main">
               <a:ext uri="{FF2B5EF4-FFF2-40B4-BE49-F238E27FC236}">
-                <a16:creationId xmlns:a16="http://schemas.microsoft.com/office/drawing/2014/main" id="{6D32C545-596D-4D1A-93DD-1FB3DE5D82DF}"/>
+                <a16:creationId xmlns:a16="http://schemas.microsoft.com/office/drawing/2014/main" id="{BEC39118-5B1A-4B78-BCFD-2678ED6AB93B}"/>
               </a:ext>
             </a:extLst>
           </p:cNvPr>
@@ -2236,7 +2305,7 @@
           <p:cNvPr id="2" name="number-3">
             <a:extLst xmlns:a="http://schemas.openxmlformats.org/drawingml/2006/main">
               <a:ext uri="{FF2B5EF4-FFF2-40B4-BE49-F238E27FC236}">
-                <a16:creationId xmlns:a16="http://schemas.microsoft.com/office/drawing/2014/main" id="{BCAD99B7-A759-4006-8C3D-1F188F57234C}"/>
+                <a16:creationId xmlns:a16="http://schemas.microsoft.com/office/drawing/2014/main" id="{4E07A627-83CD-4411-9EC8-7CC358DBA8FE}"/>
               </a:ext>
             </a:extLst>
           </p:cNvPr>
@@ -2294,7 +2363,7 @@
           <p:cNvPr id="3" name="connector-1">
             <a:extLst xmlns:a="http://schemas.openxmlformats.org/drawingml/2006/main">
               <a:ext uri="{FF2B5EF4-FFF2-40B4-BE49-F238E27FC236}">
-                <a16:creationId xmlns:a16="http://schemas.microsoft.com/office/drawing/2014/main" id="{9DE9C668-07FC-4447-81DD-B05085415190}"/>
+                <a16:creationId xmlns:a16="http://schemas.microsoft.com/office/drawing/2014/main" id="{5B1E4F6E-F0CD-42B7-B92C-03F3B5033EC9}"/>
               </a:ext>
             </a:extLst>
           </p:cNvPr>
@@ -2325,7 +2394,7 @@
           <p:cNvPr id="4" name="connector-2">
             <a:extLst xmlns:a="http://schemas.openxmlformats.org/drawingml/2006/main">
               <a:ext uri="{FF2B5EF4-FFF2-40B4-BE49-F238E27FC236}">
-                <a16:creationId xmlns:a16="http://schemas.microsoft.com/office/drawing/2014/main" id="{54402646-ABD8-496C-81C2-7B74064385AF}"/>
+                <a16:creationId xmlns:a16="http://schemas.microsoft.com/office/drawing/2014/main" id="{6F222AA5-52E9-45E1-A880-720F2473784B}"/>
               </a:ext>
             </a:extLst>
           </p:cNvPr>
@@ -2356,7 +2425,7 @@
           <p:cNvPr id="5" name="node-1">
             <a:extLst xmlns:a="http://schemas.openxmlformats.org/drawingml/2006/main">
               <a:ext uri="{FF2B5EF4-FFF2-40B4-BE49-F238E27FC236}">
-                <a16:creationId xmlns:a16="http://schemas.microsoft.com/office/drawing/2014/main" id="{0C622E16-C8B5-48ED-A71F-E454086CEF95}"/>
+                <a16:creationId xmlns:a16="http://schemas.microsoft.com/office/drawing/2014/main" id="{C7E23589-0D46-4309-AA61-CB8A10DC2842}"/>
               </a:ext>
             </a:extLst>
           </p:cNvPr>
@@ -2418,7 +2487,7 @@
           <p:cNvPr id="6" name="node-2">
             <a:extLst xmlns:a="http://schemas.openxmlformats.org/drawingml/2006/main">
               <a:ext uri="{FF2B5EF4-FFF2-40B4-BE49-F238E27FC236}">
-                <a16:creationId xmlns:a16="http://schemas.microsoft.com/office/drawing/2014/main" id="{CD8733FA-A8A2-495C-9739-DF8A665A9860}"/>
+                <a16:creationId xmlns:a16="http://schemas.microsoft.com/office/drawing/2014/main" id="{8D6C5F68-9AC5-42F9-8014-44ACA860CA0D}"/>
               </a:ext>
             </a:extLst>
           </p:cNvPr>
@@ -2480,7 +2549,7 @@
           <p:cNvPr id="7" name="node-3">
             <a:extLst xmlns:a="http://schemas.openxmlformats.org/drawingml/2006/main">
               <a:ext uri="{FF2B5EF4-FFF2-40B4-BE49-F238E27FC236}">
-                <a16:creationId xmlns:a16="http://schemas.microsoft.com/office/drawing/2014/main" id="{7E6F51C6-C2F7-4651-989E-01563FF9433F}"/>
+                <a16:creationId xmlns:a16="http://schemas.microsoft.com/office/drawing/2014/main" id="{A55E1CBC-2BE6-4B97-B675-FA55F45D066E}"/>
               </a:ext>
             </a:extLst>
           </p:cNvPr>
@@ -2542,7 +2611,7 @@
           <p:cNvPr id="8" name="diagram-footer">
             <a:extLst xmlns:a="http://schemas.openxmlformats.org/drawingml/2006/main">
               <a:ext uri="{FF2B5EF4-FFF2-40B4-BE49-F238E27FC236}">
-                <a16:creationId xmlns:a16="http://schemas.microsoft.com/office/drawing/2014/main" id="{3FED12E3-136D-45AD-91A9-EA6D0A16C588}"/>
+                <a16:creationId xmlns:a16="http://schemas.microsoft.com/office/drawing/2014/main" id="{1E6FFF9D-2BE0-4389-B1A8-CAE91C912F7E}"/>
               </a:ext>
             </a:extLst>
           </p:cNvPr>
@@ -2598,7 +2667,7 @@
     </p:spTree>
     <p:extLst>
       <p:ext uri="{BB962C8B-B14F-4D97-AF65-F5344CB8AC3E}">
-        <p14:creationId xmlns:p14="http://schemas.microsoft.com/office/powerpoint/2010/main" val="1347656116"/>
+        <p14:creationId xmlns:p14="http://schemas.microsoft.com/office/powerpoint/2010/main" val="376493168"/>
       </p:ext>
     </p:extLst>
   </p:cSld>
@@ -2629,7 +2698,7 @@
           <p:cNvPr id="15" name="title-4">
             <a:extLst xmlns:a="http://schemas.openxmlformats.org/drawingml/2006/main">
               <a:ext uri="{FF2B5EF4-FFF2-40B4-BE49-F238E27FC236}">
-                <a16:creationId xmlns:a16="http://schemas.microsoft.com/office/drawing/2014/main" id="{ED507418-2AA0-455C-BE02-ACEEA1FEAB28}"/>
+                <a16:creationId xmlns:a16="http://schemas.microsoft.com/office/drawing/2014/main" id="{021B4D0F-93FF-41B0-AF80-2102372C7CBF}"/>
               </a:ext>
             </a:extLst>
           </p:cNvPr>
@@ -2687,7 +2756,7 @@
           <p:cNvPr id="2" name="number-4">
             <a:extLst xmlns:a="http://schemas.openxmlformats.org/drawingml/2006/main">
               <a:ext uri="{FF2B5EF4-FFF2-40B4-BE49-F238E27FC236}">
-                <a16:creationId xmlns:a16="http://schemas.microsoft.com/office/drawing/2014/main" id="{49603FF9-A0CB-4926-8F77-424AB69B6778}"/>
+                <a16:creationId xmlns:a16="http://schemas.microsoft.com/office/drawing/2014/main" id="{C6501192-9B9D-4952-B257-8873ED7AAC53}"/>
               </a:ext>
             </a:extLst>
           </p:cNvPr>
@@ -2745,7 +2814,7 @@
           <p:cNvPr id="3" name="cell-0-0">
             <a:extLst xmlns:a="http://schemas.openxmlformats.org/drawingml/2006/main">
               <a:ext uri="{FF2B5EF4-FFF2-40B4-BE49-F238E27FC236}">
-                <a16:creationId xmlns:a16="http://schemas.microsoft.com/office/drawing/2014/main" id="{91BCB5EF-81A0-44ED-A8F5-7D7EDB71CCA9}"/>
+                <a16:creationId xmlns:a16="http://schemas.microsoft.com/office/drawing/2014/main" id="{2190D16E-60D9-4439-9E63-86F00C5812EE}"/>
               </a:ext>
             </a:extLst>
           </p:cNvPr>
@@ -2807,7 +2876,7 @@
           <p:cNvPr id="4" name="cell-0-1">
             <a:extLst xmlns:a="http://schemas.openxmlformats.org/drawingml/2006/main">
               <a:ext uri="{FF2B5EF4-FFF2-40B4-BE49-F238E27FC236}">
-                <a16:creationId xmlns:a16="http://schemas.microsoft.com/office/drawing/2014/main" id="{856F75FD-0271-4301-8C23-B486F146FF7F}"/>
+                <a16:creationId xmlns:a16="http://schemas.microsoft.com/office/drawing/2014/main" id="{7C37FF64-F8F7-4590-B38D-22EDC0F153F8}"/>
               </a:ext>
             </a:extLst>
           </p:cNvPr>
@@ -2869,7 +2938,7 @@
           <p:cNvPr id="5" name="cell-0-2">
             <a:extLst xmlns:a="http://schemas.openxmlformats.org/drawingml/2006/main">
               <a:ext uri="{FF2B5EF4-FFF2-40B4-BE49-F238E27FC236}">
-                <a16:creationId xmlns:a16="http://schemas.microsoft.com/office/drawing/2014/main" id="{B9D75F16-7DB1-491D-B0E2-0020F0F0E9B1}"/>
+                <a16:creationId xmlns:a16="http://schemas.microsoft.com/office/drawing/2014/main" id="{AB2FCB3E-01BE-4CC6-8838-9C83E2D6BD77}"/>
               </a:ext>
             </a:extLst>
           </p:cNvPr>
@@ -2931,7 +3000,7 @@
           <p:cNvPr id="6" name="cell-1-0">
             <a:extLst xmlns:a="http://schemas.openxmlformats.org/drawingml/2006/main">
               <a:ext uri="{FF2B5EF4-FFF2-40B4-BE49-F238E27FC236}">
-                <a16:creationId xmlns:a16="http://schemas.microsoft.com/office/drawing/2014/main" id="{EF7E5DC3-7066-41C0-BE75-608652AB9009}"/>
+                <a16:creationId xmlns:a16="http://schemas.microsoft.com/office/drawing/2014/main" id="{66B75281-F59F-4D0A-8746-C6CEB3252045}"/>
               </a:ext>
             </a:extLst>
           </p:cNvPr>
@@ -2993,7 +3062,7 @@
           <p:cNvPr id="7" name="cell-1-1">
             <a:extLst xmlns:a="http://schemas.openxmlformats.org/drawingml/2006/main">
               <a:ext uri="{FF2B5EF4-FFF2-40B4-BE49-F238E27FC236}">
-                <a16:creationId xmlns:a16="http://schemas.microsoft.com/office/drawing/2014/main" id="{EB9408BB-262A-429A-B6C1-E72999F378D8}"/>
+                <a16:creationId xmlns:a16="http://schemas.microsoft.com/office/drawing/2014/main" id="{07AE0C91-3F09-46FE-8394-4A8F132D4CA3}"/>
               </a:ext>
             </a:extLst>
           </p:cNvPr>
@@ -3055,7 +3124,7 @@
           <p:cNvPr id="8" name="cell-1-2">
             <a:extLst xmlns:a="http://schemas.openxmlformats.org/drawingml/2006/main">
               <a:ext uri="{FF2B5EF4-FFF2-40B4-BE49-F238E27FC236}">
-                <a16:creationId xmlns:a16="http://schemas.microsoft.com/office/drawing/2014/main" id="{A0870F06-C46D-416C-B067-CD1251972054}"/>
+                <a16:creationId xmlns:a16="http://schemas.microsoft.com/office/drawing/2014/main" id="{4CC69FAA-C956-4263-B501-BD064002B600}"/>
               </a:ext>
             </a:extLst>
           </p:cNvPr>
@@ -3117,7 +3186,7 @@
           <p:cNvPr id="9" name="cell-2-0">
             <a:extLst xmlns:a="http://schemas.openxmlformats.org/drawingml/2006/main">
               <a:ext uri="{FF2B5EF4-FFF2-40B4-BE49-F238E27FC236}">
-                <a16:creationId xmlns:a16="http://schemas.microsoft.com/office/drawing/2014/main" id="{5DB5441D-0F7B-4307-8FF6-93B89E5ABF20}"/>
+                <a16:creationId xmlns:a16="http://schemas.microsoft.com/office/drawing/2014/main" id="{66987612-F3C8-42C7-8463-4F644B782B19}"/>
               </a:ext>
             </a:extLst>
           </p:cNvPr>
@@ -3179,7 +3248,7 @@
           <p:cNvPr id="10" name="cell-2-1">
             <a:extLst xmlns:a="http://schemas.openxmlformats.org/drawingml/2006/main">
               <a:ext uri="{FF2B5EF4-FFF2-40B4-BE49-F238E27FC236}">
-                <a16:creationId xmlns:a16="http://schemas.microsoft.com/office/drawing/2014/main" id="{0586ED83-68C0-4BED-BBFC-D4EBDBDF3B3C}"/>
+                <a16:creationId xmlns:a16="http://schemas.microsoft.com/office/drawing/2014/main" id="{051196D0-A336-4FE1-8762-12D4896AED97}"/>
               </a:ext>
             </a:extLst>
           </p:cNvPr>
@@ -3241,7 +3310,7 @@
           <p:cNvPr id="11" name="cell-2-2">
             <a:extLst xmlns:a="http://schemas.openxmlformats.org/drawingml/2006/main">
               <a:ext uri="{FF2B5EF4-FFF2-40B4-BE49-F238E27FC236}">
-                <a16:creationId xmlns:a16="http://schemas.microsoft.com/office/drawing/2014/main" id="{94D028EF-60B2-4645-85BA-B72B9D0ACD70}"/>
+                <a16:creationId xmlns:a16="http://schemas.microsoft.com/office/drawing/2014/main" id="{A72CAD56-4C2A-417F-B3B0-89F61CA6C83A}"/>
               </a:ext>
             </a:extLst>
           </p:cNvPr>
@@ -3303,7 +3372,7 @@
           <p:cNvPr id="12" name="cell-3-0">
             <a:extLst xmlns:a="http://schemas.openxmlformats.org/drawingml/2006/main">
               <a:ext uri="{FF2B5EF4-FFF2-40B4-BE49-F238E27FC236}">
-                <a16:creationId xmlns:a16="http://schemas.microsoft.com/office/drawing/2014/main" id="{A5F2B26B-998E-40BD-9232-BFDCEB8AB595}"/>
+                <a16:creationId xmlns:a16="http://schemas.microsoft.com/office/drawing/2014/main" id="{3275F01F-CBC0-4560-9AB4-CD5F77ADF716}"/>
               </a:ext>
             </a:extLst>
           </p:cNvPr>
@@ -3365,7 +3434,7 @@
           <p:cNvPr id="13" name="cell-3-1">
             <a:extLst xmlns:a="http://schemas.openxmlformats.org/drawingml/2006/main">
               <a:ext uri="{FF2B5EF4-FFF2-40B4-BE49-F238E27FC236}">
-                <a16:creationId xmlns:a16="http://schemas.microsoft.com/office/drawing/2014/main" id="{9A51D8A8-B3D1-4AED-982B-3868C56CF5D8}"/>
+                <a16:creationId xmlns:a16="http://schemas.microsoft.com/office/drawing/2014/main" id="{01DECD9E-2BD3-46D5-AE74-E81EBBAE7326}"/>
               </a:ext>
             </a:extLst>
           </p:cNvPr>
@@ -3427,7 +3496,7 @@
           <p:cNvPr id="14" name="cell-3-2">
             <a:extLst xmlns:a="http://schemas.openxmlformats.org/drawingml/2006/main">
               <a:ext uri="{FF2B5EF4-FFF2-40B4-BE49-F238E27FC236}">
-                <a16:creationId xmlns:a16="http://schemas.microsoft.com/office/drawing/2014/main" id="{C55A9FB6-A923-496B-A360-5D1E750441AE}"/>
+                <a16:creationId xmlns:a16="http://schemas.microsoft.com/office/drawing/2014/main" id="{3E8EFAF8-348F-46AA-988B-819E25F068C6}"/>
               </a:ext>
             </a:extLst>
           </p:cNvPr>
@@ -3487,7 +3556,7 @@
     </p:spTree>
     <p:extLst>
       <p:ext uri="{BB962C8B-B14F-4D97-AF65-F5344CB8AC3E}">
-        <p14:creationId xmlns:p14="http://schemas.microsoft.com/office/powerpoint/2010/main" val="578636357"/>
+        <p14:creationId xmlns:p14="http://schemas.microsoft.com/office/powerpoint/2010/main" val="591211724"/>
       </p:ext>
     </p:extLst>
   </p:cSld>
@@ -3518,7 +3587,7 @@
           <p:cNvPr id="12" name="title-5">
             <a:extLst xmlns:a="http://schemas.openxmlformats.org/drawingml/2006/main">
               <a:ext uri="{FF2B5EF4-FFF2-40B4-BE49-F238E27FC236}">
-                <a16:creationId xmlns:a16="http://schemas.microsoft.com/office/drawing/2014/main" id="{29582642-4682-4112-BA4E-FB71B546AE86}"/>
+                <a16:creationId xmlns:a16="http://schemas.microsoft.com/office/drawing/2014/main" id="{34A3AAE0-9E8A-4721-975C-07972E6BD76E}"/>
               </a:ext>
             </a:extLst>
           </p:cNvPr>
@@ -3576,7 +3645,7 @@
           <p:cNvPr id="2" name="number-5">
             <a:extLst xmlns:a="http://schemas.openxmlformats.org/drawingml/2006/main">
               <a:ext uri="{FF2B5EF4-FFF2-40B4-BE49-F238E27FC236}">
-                <a16:creationId xmlns:a16="http://schemas.microsoft.com/office/drawing/2014/main" id="{F1C29EA5-6B19-4624-8B63-2BCB7447A90E}"/>
+                <a16:creationId xmlns:a16="http://schemas.microsoft.com/office/drawing/2014/main" id="{E62368BD-3575-4005-9196-5F369B6724D7}"/>
               </a:ext>
             </a:extLst>
           </p:cNvPr>
@@ -3634,7 +3703,7 @@
           <p:cNvPr id="3" name="stat-panel-0">
             <a:extLst xmlns:a="http://schemas.openxmlformats.org/drawingml/2006/main">
               <a:ext uri="{FF2B5EF4-FFF2-40B4-BE49-F238E27FC236}">
-                <a16:creationId xmlns:a16="http://schemas.microsoft.com/office/drawing/2014/main" id="{B51F57D1-EC9C-472D-9652-8511485CA7FF}"/>
+                <a16:creationId xmlns:a16="http://schemas.microsoft.com/office/drawing/2014/main" id="{7FB5ABD2-29A6-4B87-9991-B69A353DFC90}"/>
               </a:ext>
             </a:extLst>
           </p:cNvPr>
@@ -3665,7 +3734,7 @@
           <p:cNvPr id="4" name="stat-0">
             <a:extLst xmlns:a="http://schemas.openxmlformats.org/drawingml/2006/main">
               <a:ext uri="{FF2B5EF4-FFF2-40B4-BE49-F238E27FC236}">
-                <a16:creationId xmlns:a16="http://schemas.microsoft.com/office/drawing/2014/main" id="{43D7F894-B368-4DC3-8377-5FCB4F4B530A}"/>
+                <a16:creationId xmlns:a16="http://schemas.microsoft.com/office/drawing/2014/main" id="{53E7D76B-63D5-4116-9AD4-94CEBA3CE63C}"/>
               </a:ext>
             </a:extLst>
           </p:cNvPr>
@@ -3723,7 +3792,7 @@
           <p:cNvPr id="5" name="stat-caption-0">
             <a:extLst xmlns:a="http://schemas.openxmlformats.org/drawingml/2006/main">
               <a:ext uri="{FF2B5EF4-FFF2-40B4-BE49-F238E27FC236}">
-                <a16:creationId xmlns:a16="http://schemas.microsoft.com/office/drawing/2014/main" id="{C4BF3823-8EF8-4EC9-B928-A40442EE038D}"/>
+                <a16:creationId xmlns:a16="http://schemas.microsoft.com/office/drawing/2014/main" id="{A8E1EB90-6340-4558-8F5C-1B6C3ABAFD25}"/>
               </a:ext>
             </a:extLst>
           </p:cNvPr>
@@ -3781,7 +3850,7 @@
           <p:cNvPr id="6" name="stat-panel-1">
             <a:extLst xmlns:a="http://schemas.openxmlformats.org/drawingml/2006/main">
               <a:ext uri="{FF2B5EF4-FFF2-40B4-BE49-F238E27FC236}">
-                <a16:creationId xmlns:a16="http://schemas.microsoft.com/office/drawing/2014/main" id="{8266C388-4585-4DE9-AE3A-D64F6ABFE936}"/>
+                <a16:creationId xmlns:a16="http://schemas.microsoft.com/office/drawing/2014/main" id="{8B0435B6-D179-430F-8839-5C1E0698904F}"/>
               </a:ext>
             </a:extLst>
           </p:cNvPr>
@@ -3812,7 +3881,7 @@
           <p:cNvPr id="7" name="stat-1">
             <a:extLst xmlns:a="http://schemas.openxmlformats.org/drawingml/2006/main">
               <a:ext uri="{FF2B5EF4-FFF2-40B4-BE49-F238E27FC236}">
-                <a16:creationId xmlns:a16="http://schemas.microsoft.com/office/drawing/2014/main" id="{BB2D846D-B77B-4706-9B6E-EABF852172FB}"/>
+                <a16:creationId xmlns:a16="http://schemas.microsoft.com/office/drawing/2014/main" id="{66F43029-E234-4D06-A4B1-F21D7379ECE0}"/>
               </a:ext>
             </a:extLst>
           </p:cNvPr>
@@ -3870,7 +3939,7 @@
           <p:cNvPr id="8" name="stat-caption-1">
             <a:extLst xmlns:a="http://schemas.openxmlformats.org/drawingml/2006/main">
               <a:ext uri="{FF2B5EF4-FFF2-40B4-BE49-F238E27FC236}">
-                <a16:creationId xmlns:a16="http://schemas.microsoft.com/office/drawing/2014/main" id="{0184326D-F95E-486A-A7E3-5AE48507E2B7}"/>
+                <a16:creationId xmlns:a16="http://schemas.microsoft.com/office/drawing/2014/main" id="{93F57D78-7AA2-4EB1-BA3F-BDB22D06826B}"/>
               </a:ext>
             </a:extLst>
           </p:cNvPr>
@@ -3928,7 +3997,7 @@
           <p:cNvPr id="9" name="stat-panel-2">
             <a:extLst xmlns:a="http://schemas.openxmlformats.org/drawingml/2006/main">
               <a:ext uri="{FF2B5EF4-FFF2-40B4-BE49-F238E27FC236}">
-                <a16:creationId xmlns:a16="http://schemas.microsoft.com/office/drawing/2014/main" id="{53725E6C-B959-4D52-8188-0BCC9E51057D}"/>
+                <a16:creationId xmlns:a16="http://schemas.microsoft.com/office/drawing/2014/main" id="{55553400-1989-4927-B2EB-D1D8F7282B81}"/>
               </a:ext>
             </a:extLst>
           </p:cNvPr>
@@ -3959,7 +4028,7 @@
           <p:cNvPr id="10" name="stat-2">
             <a:extLst xmlns:a="http://schemas.openxmlformats.org/drawingml/2006/main">
               <a:ext uri="{FF2B5EF4-FFF2-40B4-BE49-F238E27FC236}">
-                <a16:creationId xmlns:a16="http://schemas.microsoft.com/office/drawing/2014/main" id="{33AB42A1-2F12-46B6-99FA-49F1AF7B1AC6}"/>
+                <a16:creationId xmlns:a16="http://schemas.microsoft.com/office/drawing/2014/main" id="{CD05045F-6667-4C25-AA9D-BC562E4A002E}"/>
               </a:ext>
             </a:extLst>
           </p:cNvPr>
@@ -4017,7 +4086,7 @@
           <p:cNvPr id="11" name="stat-caption-2">
             <a:extLst xmlns:a="http://schemas.openxmlformats.org/drawingml/2006/main">
               <a:ext uri="{FF2B5EF4-FFF2-40B4-BE49-F238E27FC236}">
-                <a16:creationId xmlns:a16="http://schemas.microsoft.com/office/drawing/2014/main" id="{2321BD0A-D80E-4453-81FA-B20752715E7C}"/>
+                <a16:creationId xmlns:a16="http://schemas.microsoft.com/office/drawing/2014/main" id="{04383100-D036-41F4-BE96-7086DA225C73}"/>
               </a:ext>
             </a:extLst>
           </p:cNvPr>
@@ -4073,7 +4142,7 @@
     </p:spTree>
     <p:extLst>
       <p:ext uri="{BB962C8B-B14F-4D97-AF65-F5344CB8AC3E}">
-        <p14:creationId xmlns:p14="http://schemas.microsoft.com/office/powerpoint/2010/main" val="925281673"/>
+        <p14:creationId xmlns:p14="http://schemas.microsoft.com/office/powerpoint/2010/main" val="761193007"/>
       </p:ext>
     </p:extLst>
   </p:cSld>
@@ -4104,7 +4173,7 @@
           <p:cNvPr id="10" name="title-6">
             <a:extLst xmlns:a="http://schemas.openxmlformats.org/drawingml/2006/main">
               <a:ext uri="{FF2B5EF4-FFF2-40B4-BE49-F238E27FC236}">
-                <a16:creationId xmlns:a16="http://schemas.microsoft.com/office/drawing/2014/main" id="{59E0526F-FDC7-4B72-BE1E-54F7BE74903B}"/>
+                <a16:creationId xmlns:a16="http://schemas.microsoft.com/office/drawing/2014/main" id="{68DF847C-CE0E-4965-9294-423F2FB3D8EA}"/>
               </a:ext>
             </a:extLst>
           </p:cNvPr>
@@ -4162,7 +4231,7 @@
           <p:cNvPr id="2" name="number-6">
             <a:extLst xmlns:a="http://schemas.openxmlformats.org/drawingml/2006/main">
               <a:ext uri="{FF2B5EF4-FFF2-40B4-BE49-F238E27FC236}">
-                <a16:creationId xmlns:a16="http://schemas.microsoft.com/office/drawing/2014/main" id="{11E3A510-B53D-4FF7-8ABB-0FCFC8CBEB8F}"/>
+                <a16:creationId xmlns:a16="http://schemas.microsoft.com/office/drawing/2014/main" id="{32ABBBBA-730A-4895-8B83-E2C0C526E8AF}"/>
               </a:ext>
             </a:extLst>
           </p:cNvPr>
@@ -4220,7 +4289,7 @@
           <p:cNvPr id="3" name="step-num-0">
             <a:extLst xmlns:a="http://schemas.openxmlformats.org/drawingml/2006/main">
               <a:ext uri="{FF2B5EF4-FFF2-40B4-BE49-F238E27FC236}">
-                <a16:creationId xmlns:a16="http://schemas.microsoft.com/office/drawing/2014/main" id="{7CD0E520-C475-49AE-9B94-B90625686450}"/>
+                <a16:creationId xmlns:a16="http://schemas.microsoft.com/office/drawing/2014/main" id="{6C189C4F-79BC-4D95-95C5-CCC6C5AF14E5}"/>
               </a:ext>
             </a:extLst>
           </p:cNvPr>
@@ -4280,7 +4349,7 @@
           <p:cNvPr id="4" name="step-0">
             <a:extLst xmlns:a="http://schemas.openxmlformats.org/drawingml/2006/main">
               <a:ext uri="{FF2B5EF4-FFF2-40B4-BE49-F238E27FC236}">
-                <a16:creationId xmlns:a16="http://schemas.microsoft.com/office/drawing/2014/main" id="{CB31C8A2-5CDC-470A-99FB-130B16B5FC4C}"/>
+                <a16:creationId xmlns:a16="http://schemas.microsoft.com/office/drawing/2014/main" id="{97656E5F-32F7-4610-9705-E5C9702A46D2}"/>
               </a:ext>
             </a:extLst>
           </p:cNvPr>
@@ -4338,7 +4407,7 @@
           <p:cNvPr id="5" name="step-num-1">
             <a:extLst xmlns:a="http://schemas.openxmlformats.org/drawingml/2006/main">
               <a:ext uri="{FF2B5EF4-FFF2-40B4-BE49-F238E27FC236}">
-                <a16:creationId xmlns:a16="http://schemas.microsoft.com/office/drawing/2014/main" id="{5EBBD613-EAFE-459E-AE47-8B3181230D87}"/>
+                <a16:creationId xmlns:a16="http://schemas.microsoft.com/office/drawing/2014/main" id="{F4D36D1D-C1DE-4346-8AAA-0B784529CFCB}"/>
               </a:ext>
             </a:extLst>
           </p:cNvPr>
@@ -4398,7 +4467,7 @@
           <p:cNvPr id="6" name="step-1">
             <a:extLst xmlns:a="http://schemas.openxmlformats.org/drawingml/2006/main">
               <a:ext uri="{FF2B5EF4-FFF2-40B4-BE49-F238E27FC236}">
-                <a16:creationId xmlns:a16="http://schemas.microsoft.com/office/drawing/2014/main" id="{F7694CA0-F53C-4575-8DEA-E731607C2517}"/>
+                <a16:creationId xmlns:a16="http://schemas.microsoft.com/office/drawing/2014/main" id="{6701065E-F770-4F28-9E17-5F81ECF5837E}"/>
               </a:ext>
             </a:extLst>
           </p:cNvPr>
@@ -4456,7 +4525,7 @@
           <p:cNvPr id="7" name="step-num-2">
             <a:extLst xmlns:a="http://schemas.openxmlformats.org/drawingml/2006/main">
               <a:ext uri="{FF2B5EF4-FFF2-40B4-BE49-F238E27FC236}">
-                <a16:creationId xmlns:a16="http://schemas.microsoft.com/office/drawing/2014/main" id="{DC047474-8D01-4B24-9F05-EEFD3AED2D71}"/>
+                <a16:creationId xmlns:a16="http://schemas.microsoft.com/office/drawing/2014/main" id="{CEAFFDC1-376E-4D2A-B550-B2BB62D8FF3B}"/>
               </a:ext>
             </a:extLst>
           </p:cNvPr>
@@ -4516,7 +4585,7 @@
           <p:cNvPr id="8" name="step-2">
             <a:extLst xmlns:a="http://schemas.openxmlformats.org/drawingml/2006/main">
               <a:ext uri="{FF2B5EF4-FFF2-40B4-BE49-F238E27FC236}">
-                <a16:creationId xmlns:a16="http://schemas.microsoft.com/office/drawing/2014/main" id="{D37EE0D6-32B9-4CCC-B013-C7434950FD40}"/>
+                <a16:creationId xmlns:a16="http://schemas.microsoft.com/office/drawing/2014/main" id="{A0531FF2-72CD-4659-8DE0-3A4D1A027480}"/>
               </a:ext>
             </a:extLst>
           </p:cNvPr>
@@ -4574,7 +4643,7 @@
           <p:cNvPr id="9" name="result-status">
             <a:extLst xmlns:a="http://schemas.openxmlformats.org/drawingml/2006/main">
               <a:ext uri="{FF2B5EF4-FFF2-40B4-BE49-F238E27FC236}">
-                <a16:creationId xmlns:a16="http://schemas.microsoft.com/office/drawing/2014/main" id="{18F89460-06A2-459B-89AD-FD94886E6F6C}"/>
+                <a16:creationId xmlns:a16="http://schemas.microsoft.com/office/drawing/2014/main" id="{6F02BDB2-4CBB-46B7-82AE-92E7C0E210C3}"/>
               </a:ext>
             </a:extLst>
           </p:cNvPr>
@@ -4630,7 +4699,7 @@
     </p:spTree>
     <p:extLst>
       <p:ext uri="{BB962C8B-B14F-4D97-AF65-F5344CB8AC3E}">
-        <p14:creationId xmlns:p14="http://schemas.microsoft.com/office/powerpoint/2010/main" val="1945722316"/>
+        <p14:creationId xmlns:p14="http://schemas.microsoft.com/office/powerpoint/2010/main" val="1768814285"/>
       </p:ext>
     </p:extLst>
   </p:cSld>

</xml_diff>

<commit_message>
fix: preserve Korean document phrase boundaries
</commit_message>
<xml_diff>
--- a/tests/formats/output/career-entry-12-week-roadmap/brief.pptx
+++ b/tests/formats/output/career-entry-12-week-roadmap/brief.pptx
@@ -2,18 +2,18 @@
 <file path=ppt/presentation.xml><?xml version="1.0" encoding="utf-8"?>
 <p:presentation xmlns:p="http://schemas.openxmlformats.org/presentationml/2006/main">
   <p:sldMasterIdLst>
-    <p:sldMasterId xmlns:r="http://schemas.openxmlformats.org/officeDocument/2006/relationships" id="2147483648" r:id="R1e5a64b0d9804264"/>
+    <p:sldMasterId xmlns:r="http://schemas.openxmlformats.org/officeDocument/2006/relationships" id="2147483648" r:id="R82a878b80a064f6f"/>
   </p:sldMasterIdLst>
   <p:notesMasterIdLst>
-    <p:notesMasterId xmlns:r="http://schemas.openxmlformats.org/officeDocument/2006/relationships" r:id="Rc53bcc8a7fc74b56"/>
+    <p:notesMasterId xmlns:r="http://schemas.openxmlformats.org/officeDocument/2006/relationships" r:id="R249e77450530425c"/>
   </p:notesMasterIdLst>
   <p:sldIdLst>
-    <p:sldId xmlns:r="http://schemas.openxmlformats.org/officeDocument/2006/relationships" id="256" r:id="Rd762b0922e4043f5"/>
-    <p:sldId xmlns:r="http://schemas.openxmlformats.org/officeDocument/2006/relationships" id="257" r:id="Rc42f579c405140a0"/>
-    <p:sldId xmlns:r="http://schemas.openxmlformats.org/officeDocument/2006/relationships" id="258" r:id="R8aed27db57dd4d43"/>
-    <p:sldId xmlns:r="http://schemas.openxmlformats.org/officeDocument/2006/relationships" id="259" r:id="R86b121e052a3429d"/>
-    <p:sldId xmlns:r="http://schemas.openxmlformats.org/officeDocument/2006/relationships" id="260" r:id="Rfcd99ede23b441ed"/>
-    <p:sldId xmlns:r="http://schemas.openxmlformats.org/officeDocument/2006/relationships" id="261" r:id="R4c26575ff6a34888"/>
+    <p:sldId xmlns:r="http://schemas.openxmlformats.org/officeDocument/2006/relationships" id="256" r:id="R789928fe4dc848a4"/>
+    <p:sldId xmlns:r="http://schemas.openxmlformats.org/officeDocument/2006/relationships" id="257" r:id="R3b0076090e914e27"/>
+    <p:sldId xmlns:r="http://schemas.openxmlformats.org/officeDocument/2006/relationships" id="258" r:id="Rb080af673a474b2e"/>
+    <p:sldId xmlns:r="http://schemas.openxmlformats.org/officeDocument/2006/relationships" id="259" r:id="R09559fd4c1ce4eb0"/>
+    <p:sldId xmlns:r="http://schemas.openxmlformats.org/officeDocument/2006/relationships" id="260" r:id="R33f4d78f4cfc4c24"/>
+    <p:sldId xmlns:r="http://schemas.openxmlformats.org/officeDocument/2006/relationships" id="261" r:id="R6b07ac4c3ba2401e"/>
   </p:sldIdLst>
   <p:sldSz cx="12192000" cy="6858000"/>
   <p:notesSz cx="6858000" cy="9144000"/>
@@ -900,7 +900,7 @@
   </p:cSld>
   <p:clrMap bg1="lt1" tx1="dk1" bg2="lt2" tx2="dk2" accent1="accent1" accent2="accent2" accent3="accent3" accent4="accent4" accent5="accent5" accent6="accent6" hlink="hlink" folHlink="folHlink"/>
   <p:sldLayoutIdLst>
-    <p:sldLayoutId xmlns:r="http://schemas.openxmlformats.org/officeDocument/2006/relationships" id="2147483649" r:id="Rc0248f2a0c554340"/>
+    <p:sldLayoutId xmlns:r="http://schemas.openxmlformats.org/officeDocument/2006/relationships" id="2147483649" r:id="Rf3a89ef060424030"/>
   </p:sldLayoutIdLst>
   <p:txStyles>
     <p:titleStyle>
@@ -1451,7 +1451,7 @@
           <p:cNvPr id="7" name="cover-kicker">
             <a:extLst xmlns:a="http://schemas.openxmlformats.org/drawingml/2006/main">
               <a:ext uri="{FF2B5EF4-FFF2-40B4-BE49-F238E27FC236}">
-                <a16:creationId xmlns:a16="http://schemas.microsoft.com/office/drawing/2014/main" id="{CDCA994D-D044-410B-B1E1-DD84347E1D48}"/>
+                <a16:creationId xmlns:a16="http://schemas.microsoft.com/office/drawing/2014/main" id="{8E2D217A-2749-48E7-9041-7332C0C6CAB6}"/>
               </a:ext>
             </a:extLst>
           </p:cNvPr>
@@ -1509,7 +1509,7 @@
           <p:cNvPr id="2" name="cover-title">
             <a:extLst xmlns:a="http://schemas.openxmlformats.org/drawingml/2006/main">
               <a:ext uri="{FF2B5EF4-FFF2-40B4-BE49-F238E27FC236}">
-                <a16:creationId xmlns:a16="http://schemas.microsoft.com/office/drawing/2014/main" id="{1A28FDD8-BF72-42CD-A7BF-1FC8BC371827}"/>
+                <a16:creationId xmlns:a16="http://schemas.microsoft.com/office/drawing/2014/main" id="{EB1087DC-B66A-4D5F-9C53-1CEF88DBC834}"/>
               </a:ext>
             </a:extLst>
           </p:cNvPr>
@@ -1590,7 +1590,7 @@
           <p:cNvPr id="3" name="cover-subtitle">
             <a:extLst xmlns:a="http://schemas.openxmlformats.org/drawingml/2006/main">
               <a:ext uri="{FF2B5EF4-FFF2-40B4-BE49-F238E27FC236}">
-                <a16:creationId xmlns:a16="http://schemas.microsoft.com/office/drawing/2014/main" id="{838E68D1-A210-404C-BF04-08C855724693}"/>
+                <a16:creationId xmlns:a16="http://schemas.microsoft.com/office/drawing/2014/main" id="{77B4FFE1-05FA-4F3E-B695-D2BA94700C62}"/>
               </a:ext>
             </a:extLst>
           </p:cNvPr>
@@ -1648,7 +1648,7 @@
           <p:cNvPr id="4" name="cover-panel">
             <a:extLst xmlns:a="http://schemas.openxmlformats.org/drawingml/2006/main">
               <a:ext uri="{FF2B5EF4-FFF2-40B4-BE49-F238E27FC236}">
-                <a16:creationId xmlns:a16="http://schemas.microsoft.com/office/drawing/2014/main" id="{0BCA5AFB-2CE2-4B11-BA10-D8D9872E589B}"/>
+                <a16:creationId xmlns:a16="http://schemas.microsoft.com/office/drawing/2014/main" id="{7FADE4B5-885F-4DFD-95CB-6363D26805FC}"/>
               </a:ext>
             </a:extLst>
           </p:cNvPr>
@@ -1681,7 +1681,7 @@
           <p:cNvPr id="5" name="cover-mark">
             <a:extLst xmlns:a="http://schemas.openxmlformats.org/drawingml/2006/main">
               <a:ext uri="{FF2B5EF4-FFF2-40B4-BE49-F238E27FC236}">
-                <a16:creationId xmlns:a16="http://schemas.microsoft.com/office/drawing/2014/main" id="{7E870C03-6473-4757-BFEF-2B6BBDBCDD29}"/>
+                <a16:creationId xmlns:a16="http://schemas.microsoft.com/office/drawing/2014/main" id="{16AE0822-39D9-44D7-9982-5D3FF78CBB1C}"/>
               </a:ext>
             </a:extLst>
           </p:cNvPr>
@@ -1739,7 +1739,7 @@
           <p:cNvPr id="6" name="cover-caption">
             <a:extLst xmlns:a="http://schemas.openxmlformats.org/drawingml/2006/main">
               <a:ext uri="{FF2B5EF4-FFF2-40B4-BE49-F238E27FC236}">
-                <a16:creationId xmlns:a16="http://schemas.microsoft.com/office/drawing/2014/main" id="{751A76AA-1A17-46BD-96C2-68B1DEE13126}"/>
+                <a16:creationId xmlns:a16="http://schemas.microsoft.com/office/drawing/2014/main" id="{0261FD3E-F476-417F-A305-E44B034A81FF}"/>
               </a:ext>
             </a:extLst>
           </p:cNvPr>
@@ -1795,7 +1795,7 @@
     </p:spTree>
     <p:extLst>
       <p:ext uri="{BB962C8B-B14F-4D97-AF65-F5344CB8AC3E}">
-        <p14:creationId xmlns:p14="http://schemas.microsoft.com/office/powerpoint/2010/main" val="2102220878"/>
+        <p14:creationId xmlns:p14="http://schemas.microsoft.com/office/powerpoint/2010/main" val="445010484"/>
       </p:ext>
     </p:extLst>
   </p:cSld>
@@ -1826,7 +1826,7 @@
           <p:cNvPr id="7" name="title-2">
             <a:extLst xmlns:a="http://schemas.openxmlformats.org/drawingml/2006/main">
               <a:ext uri="{FF2B5EF4-FFF2-40B4-BE49-F238E27FC236}">
-                <a16:creationId xmlns:a16="http://schemas.microsoft.com/office/drawing/2014/main" id="{0BAD957D-65FF-4DF0-B8E3-89F3E44745B0}"/>
+                <a16:creationId xmlns:a16="http://schemas.microsoft.com/office/drawing/2014/main" id="{2B68ACA3-2EB7-45E6-A488-A20E5FF30C4C}"/>
               </a:ext>
             </a:extLst>
           </p:cNvPr>
@@ -1884,7 +1884,7 @@
           <p:cNvPr id="2" name="number-2">
             <a:extLst xmlns:a="http://schemas.openxmlformats.org/drawingml/2006/main">
               <a:ext uri="{FF2B5EF4-FFF2-40B4-BE49-F238E27FC236}">
-                <a16:creationId xmlns:a16="http://schemas.microsoft.com/office/drawing/2014/main" id="{2BC16523-798B-4247-8EBF-9C84626E2FFF}"/>
+                <a16:creationId xmlns:a16="http://schemas.microsoft.com/office/drawing/2014/main" id="{D3762AA9-0051-4912-A344-7AB2C5CAC0F4}"/>
               </a:ext>
             </a:extLst>
           </p:cNvPr>
@@ -1942,7 +1942,7 @@
           <p:cNvPr id="3" name="half-body">
             <a:extLst xmlns:a="http://schemas.openxmlformats.org/drawingml/2006/main">
               <a:ext uri="{FF2B5EF4-FFF2-40B4-BE49-F238E27FC236}">
-                <a16:creationId xmlns:a16="http://schemas.microsoft.com/office/drawing/2014/main" id="{A01F173B-BC0B-4588-A085-962344218C39}"/>
+                <a16:creationId xmlns:a16="http://schemas.microsoft.com/office/drawing/2014/main" id="{CA9925F2-E5B3-4A43-8907-EC04F9C2147E}"/>
               </a:ext>
             </a:extLst>
           </p:cNvPr>
@@ -2069,7 +2069,7 @@
           <p:cNvPr id="4" name="half-visual">
             <a:extLst xmlns:a="http://schemas.openxmlformats.org/drawingml/2006/main">
               <a:ext uri="{FF2B5EF4-FFF2-40B4-BE49-F238E27FC236}">
-                <a16:creationId xmlns:a16="http://schemas.microsoft.com/office/drawing/2014/main" id="{F68231D5-A44A-4579-A9C1-B16DE36BB70A}"/>
+                <a16:creationId xmlns:a16="http://schemas.microsoft.com/office/drawing/2014/main" id="{8CF61DE9-B439-45C0-BB08-1F4B913F7A58}"/>
               </a:ext>
             </a:extLst>
           </p:cNvPr>
@@ -2102,7 +2102,7 @@
           <p:cNvPr id="5" name="half-signal">
             <a:extLst xmlns:a="http://schemas.openxmlformats.org/drawingml/2006/main">
               <a:ext uri="{FF2B5EF4-FFF2-40B4-BE49-F238E27FC236}">
-                <a16:creationId xmlns:a16="http://schemas.microsoft.com/office/drawing/2014/main" id="{3DB4BF3E-B80F-4963-978E-850F51A5EC02}"/>
+                <a16:creationId xmlns:a16="http://schemas.microsoft.com/office/drawing/2014/main" id="{0D5F9126-0825-4E60-B204-80D5EB186B93}"/>
               </a:ext>
             </a:extLst>
           </p:cNvPr>
@@ -2160,7 +2160,7 @@
           <p:cNvPr id="6" name="half-caption">
             <a:extLst xmlns:a="http://schemas.openxmlformats.org/drawingml/2006/main">
               <a:ext uri="{FF2B5EF4-FFF2-40B4-BE49-F238E27FC236}">
-                <a16:creationId xmlns:a16="http://schemas.microsoft.com/office/drawing/2014/main" id="{CDD52452-9CB5-4EB6-B760-A6EDBFC0A01D}"/>
+                <a16:creationId xmlns:a16="http://schemas.microsoft.com/office/drawing/2014/main" id="{88F84F05-8D6A-4308-97F1-8E273BBEDC7C}"/>
               </a:ext>
             </a:extLst>
           </p:cNvPr>
@@ -2216,7 +2216,7 @@
     </p:spTree>
     <p:extLst>
       <p:ext uri="{BB962C8B-B14F-4D97-AF65-F5344CB8AC3E}">
-        <p14:creationId xmlns:p14="http://schemas.microsoft.com/office/powerpoint/2010/main" val="1393789165"/>
+        <p14:creationId xmlns:p14="http://schemas.microsoft.com/office/powerpoint/2010/main" val="535823582"/>
       </p:ext>
     </p:extLst>
   </p:cSld>
@@ -2247,7 +2247,7 @@
           <p:cNvPr id="9" name="title-3">
             <a:extLst xmlns:a="http://schemas.openxmlformats.org/drawingml/2006/main">
               <a:ext uri="{FF2B5EF4-FFF2-40B4-BE49-F238E27FC236}">
-                <a16:creationId xmlns:a16="http://schemas.microsoft.com/office/drawing/2014/main" id="{BEC39118-5B1A-4B78-BCFD-2678ED6AB93B}"/>
+                <a16:creationId xmlns:a16="http://schemas.microsoft.com/office/drawing/2014/main" id="{0F5998E9-C230-443B-932E-529D94C3C9F7}"/>
               </a:ext>
             </a:extLst>
           </p:cNvPr>
@@ -2305,7 +2305,7 @@
           <p:cNvPr id="2" name="number-3">
             <a:extLst xmlns:a="http://schemas.openxmlformats.org/drawingml/2006/main">
               <a:ext uri="{FF2B5EF4-FFF2-40B4-BE49-F238E27FC236}">
-                <a16:creationId xmlns:a16="http://schemas.microsoft.com/office/drawing/2014/main" id="{4E07A627-83CD-4411-9EC8-7CC358DBA8FE}"/>
+                <a16:creationId xmlns:a16="http://schemas.microsoft.com/office/drawing/2014/main" id="{B7076162-907F-4DA6-80C8-D73F4A41FA89}"/>
               </a:ext>
             </a:extLst>
           </p:cNvPr>
@@ -2363,7 +2363,7 @@
           <p:cNvPr id="3" name="connector-1">
             <a:extLst xmlns:a="http://schemas.openxmlformats.org/drawingml/2006/main">
               <a:ext uri="{FF2B5EF4-FFF2-40B4-BE49-F238E27FC236}">
-                <a16:creationId xmlns:a16="http://schemas.microsoft.com/office/drawing/2014/main" id="{5B1E4F6E-F0CD-42B7-B92C-03F3B5033EC9}"/>
+                <a16:creationId xmlns:a16="http://schemas.microsoft.com/office/drawing/2014/main" id="{EAD62E5F-A7B3-4CA8-B620-3231A6D1643F}"/>
               </a:ext>
             </a:extLst>
           </p:cNvPr>
@@ -2394,7 +2394,7 @@
           <p:cNvPr id="4" name="connector-2">
             <a:extLst xmlns:a="http://schemas.openxmlformats.org/drawingml/2006/main">
               <a:ext uri="{FF2B5EF4-FFF2-40B4-BE49-F238E27FC236}">
-                <a16:creationId xmlns:a16="http://schemas.microsoft.com/office/drawing/2014/main" id="{6F222AA5-52E9-45E1-A880-720F2473784B}"/>
+                <a16:creationId xmlns:a16="http://schemas.microsoft.com/office/drawing/2014/main" id="{21E11897-4607-444C-9C3A-5A9CBBA49B50}"/>
               </a:ext>
             </a:extLst>
           </p:cNvPr>
@@ -2425,7 +2425,7 @@
           <p:cNvPr id="5" name="node-1">
             <a:extLst xmlns:a="http://schemas.openxmlformats.org/drawingml/2006/main">
               <a:ext uri="{FF2B5EF4-FFF2-40B4-BE49-F238E27FC236}">
-                <a16:creationId xmlns:a16="http://schemas.microsoft.com/office/drawing/2014/main" id="{C7E23589-0D46-4309-AA61-CB8A10DC2842}"/>
+                <a16:creationId xmlns:a16="http://schemas.microsoft.com/office/drawing/2014/main" id="{9EE2F986-FBEE-4847-9391-A278131914F6}"/>
               </a:ext>
             </a:extLst>
           </p:cNvPr>
@@ -2487,7 +2487,7 @@
           <p:cNvPr id="6" name="node-2">
             <a:extLst xmlns:a="http://schemas.openxmlformats.org/drawingml/2006/main">
               <a:ext uri="{FF2B5EF4-FFF2-40B4-BE49-F238E27FC236}">
-                <a16:creationId xmlns:a16="http://schemas.microsoft.com/office/drawing/2014/main" id="{8D6C5F68-9AC5-42F9-8014-44ACA860CA0D}"/>
+                <a16:creationId xmlns:a16="http://schemas.microsoft.com/office/drawing/2014/main" id="{A46F532D-F346-4EE7-9671-D21718566E1C}"/>
               </a:ext>
             </a:extLst>
           </p:cNvPr>
@@ -2549,7 +2549,7 @@
           <p:cNvPr id="7" name="node-3">
             <a:extLst xmlns:a="http://schemas.openxmlformats.org/drawingml/2006/main">
               <a:ext uri="{FF2B5EF4-FFF2-40B4-BE49-F238E27FC236}">
-                <a16:creationId xmlns:a16="http://schemas.microsoft.com/office/drawing/2014/main" id="{A55E1CBC-2BE6-4B97-B675-FA55F45D066E}"/>
+                <a16:creationId xmlns:a16="http://schemas.microsoft.com/office/drawing/2014/main" id="{649ABF29-581D-4107-8A3C-993D8D8F9B45}"/>
               </a:ext>
             </a:extLst>
           </p:cNvPr>
@@ -2611,7 +2611,7 @@
           <p:cNvPr id="8" name="diagram-footer">
             <a:extLst xmlns:a="http://schemas.openxmlformats.org/drawingml/2006/main">
               <a:ext uri="{FF2B5EF4-FFF2-40B4-BE49-F238E27FC236}">
-                <a16:creationId xmlns:a16="http://schemas.microsoft.com/office/drawing/2014/main" id="{1E6FFF9D-2BE0-4389-B1A8-CAE91C912F7E}"/>
+                <a16:creationId xmlns:a16="http://schemas.microsoft.com/office/drawing/2014/main" id="{75F54342-9582-47EF-AA89-2A524A63B34D}"/>
               </a:ext>
             </a:extLst>
           </p:cNvPr>
@@ -2667,7 +2667,7 @@
     </p:spTree>
     <p:extLst>
       <p:ext uri="{BB962C8B-B14F-4D97-AF65-F5344CB8AC3E}">
-        <p14:creationId xmlns:p14="http://schemas.microsoft.com/office/powerpoint/2010/main" val="376493168"/>
+        <p14:creationId xmlns:p14="http://schemas.microsoft.com/office/powerpoint/2010/main" val="1838427600"/>
       </p:ext>
     </p:extLst>
   </p:cSld>
@@ -2698,7 +2698,7 @@
           <p:cNvPr id="15" name="title-4">
             <a:extLst xmlns:a="http://schemas.openxmlformats.org/drawingml/2006/main">
               <a:ext uri="{FF2B5EF4-FFF2-40B4-BE49-F238E27FC236}">
-                <a16:creationId xmlns:a16="http://schemas.microsoft.com/office/drawing/2014/main" id="{021B4D0F-93FF-41B0-AF80-2102372C7CBF}"/>
+                <a16:creationId xmlns:a16="http://schemas.microsoft.com/office/drawing/2014/main" id="{BBCDD95F-775C-4C1E-833B-2B98B2CB0834}"/>
               </a:ext>
             </a:extLst>
           </p:cNvPr>
@@ -2756,7 +2756,7 @@
           <p:cNvPr id="2" name="number-4">
             <a:extLst xmlns:a="http://schemas.openxmlformats.org/drawingml/2006/main">
               <a:ext uri="{FF2B5EF4-FFF2-40B4-BE49-F238E27FC236}">
-                <a16:creationId xmlns:a16="http://schemas.microsoft.com/office/drawing/2014/main" id="{C6501192-9B9D-4952-B257-8873ED7AAC53}"/>
+                <a16:creationId xmlns:a16="http://schemas.microsoft.com/office/drawing/2014/main" id="{55E9DFCC-3457-4F99-80E5-C9428037FECF}"/>
               </a:ext>
             </a:extLst>
           </p:cNvPr>
@@ -2814,7 +2814,7 @@
           <p:cNvPr id="3" name="cell-0-0">
             <a:extLst xmlns:a="http://schemas.openxmlformats.org/drawingml/2006/main">
               <a:ext uri="{FF2B5EF4-FFF2-40B4-BE49-F238E27FC236}">
-                <a16:creationId xmlns:a16="http://schemas.microsoft.com/office/drawing/2014/main" id="{2190D16E-60D9-4439-9E63-86F00C5812EE}"/>
+                <a16:creationId xmlns:a16="http://schemas.microsoft.com/office/drawing/2014/main" id="{E949515E-6017-42A4-B8E7-AAADC3BB08F7}"/>
               </a:ext>
             </a:extLst>
           </p:cNvPr>
@@ -2876,7 +2876,7 @@
           <p:cNvPr id="4" name="cell-0-1">
             <a:extLst xmlns:a="http://schemas.openxmlformats.org/drawingml/2006/main">
               <a:ext uri="{FF2B5EF4-FFF2-40B4-BE49-F238E27FC236}">
-                <a16:creationId xmlns:a16="http://schemas.microsoft.com/office/drawing/2014/main" id="{7C37FF64-F8F7-4590-B38D-22EDC0F153F8}"/>
+                <a16:creationId xmlns:a16="http://schemas.microsoft.com/office/drawing/2014/main" id="{7A020E8F-6AAC-433C-B639-905BBBBEBF24}"/>
               </a:ext>
             </a:extLst>
           </p:cNvPr>
@@ -2938,7 +2938,7 @@
           <p:cNvPr id="5" name="cell-0-2">
             <a:extLst xmlns:a="http://schemas.openxmlformats.org/drawingml/2006/main">
               <a:ext uri="{FF2B5EF4-FFF2-40B4-BE49-F238E27FC236}">
-                <a16:creationId xmlns:a16="http://schemas.microsoft.com/office/drawing/2014/main" id="{AB2FCB3E-01BE-4CC6-8838-9C83E2D6BD77}"/>
+                <a16:creationId xmlns:a16="http://schemas.microsoft.com/office/drawing/2014/main" id="{0E511EE6-179D-4539-81DC-CCB05797FE40}"/>
               </a:ext>
             </a:extLst>
           </p:cNvPr>
@@ -3000,7 +3000,7 @@
           <p:cNvPr id="6" name="cell-1-0">
             <a:extLst xmlns:a="http://schemas.openxmlformats.org/drawingml/2006/main">
               <a:ext uri="{FF2B5EF4-FFF2-40B4-BE49-F238E27FC236}">
-                <a16:creationId xmlns:a16="http://schemas.microsoft.com/office/drawing/2014/main" id="{66B75281-F59F-4D0A-8746-C6CEB3252045}"/>
+                <a16:creationId xmlns:a16="http://schemas.microsoft.com/office/drawing/2014/main" id="{627B7202-F72C-4BF0-8A76-7BBC7DC73433}"/>
               </a:ext>
             </a:extLst>
           </p:cNvPr>
@@ -3062,7 +3062,7 @@
           <p:cNvPr id="7" name="cell-1-1">
             <a:extLst xmlns:a="http://schemas.openxmlformats.org/drawingml/2006/main">
               <a:ext uri="{FF2B5EF4-FFF2-40B4-BE49-F238E27FC236}">
-                <a16:creationId xmlns:a16="http://schemas.microsoft.com/office/drawing/2014/main" id="{07AE0C91-3F09-46FE-8394-4A8F132D4CA3}"/>
+                <a16:creationId xmlns:a16="http://schemas.microsoft.com/office/drawing/2014/main" id="{755EA783-2FF9-45F2-B0E0-7831E2289910}"/>
               </a:ext>
             </a:extLst>
           </p:cNvPr>
@@ -3124,7 +3124,7 @@
           <p:cNvPr id="8" name="cell-1-2">
             <a:extLst xmlns:a="http://schemas.openxmlformats.org/drawingml/2006/main">
               <a:ext uri="{FF2B5EF4-FFF2-40B4-BE49-F238E27FC236}">
-                <a16:creationId xmlns:a16="http://schemas.microsoft.com/office/drawing/2014/main" id="{4CC69FAA-C956-4263-B501-BD064002B600}"/>
+                <a16:creationId xmlns:a16="http://schemas.microsoft.com/office/drawing/2014/main" id="{7A993964-5679-45DB-8195-971D2863DF61}"/>
               </a:ext>
             </a:extLst>
           </p:cNvPr>
@@ -3186,7 +3186,7 @@
           <p:cNvPr id="9" name="cell-2-0">
             <a:extLst xmlns:a="http://schemas.openxmlformats.org/drawingml/2006/main">
               <a:ext uri="{FF2B5EF4-FFF2-40B4-BE49-F238E27FC236}">
-                <a16:creationId xmlns:a16="http://schemas.microsoft.com/office/drawing/2014/main" id="{66987612-F3C8-42C7-8463-4F644B782B19}"/>
+                <a16:creationId xmlns:a16="http://schemas.microsoft.com/office/drawing/2014/main" id="{DA484E96-463A-4039-8CB9-54E6957A5CB7}"/>
               </a:ext>
             </a:extLst>
           </p:cNvPr>
@@ -3248,7 +3248,7 @@
           <p:cNvPr id="10" name="cell-2-1">
             <a:extLst xmlns:a="http://schemas.openxmlformats.org/drawingml/2006/main">
               <a:ext uri="{FF2B5EF4-FFF2-40B4-BE49-F238E27FC236}">
-                <a16:creationId xmlns:a16="http://schemas.microsoft.com/office/drawing/2014/main" id="{051196D0-A336-4FE1-8762-12D4896AED97}"/>
+                <a16:creationId xmlns:a16="http://schemas.microsoft.com/office/drawing/2014/main" id="{D17B2D85-D426-4054-B7D8-B237FEE560B8}"/>
               </a:ext>
             </a:extLst>
           </p:cNvPr>
@@ -3310,7 +3310,7 @@
           <p:cNvPr id="11" name="cell-2-2">
             <a:extLst xmlns:a="http://schemas.openxmlformats.org/drawingml/2006/main">
               <a:ext uri="{FF2B5EF4-FFF2-40B4-BE49-F238E27FC236}">
-                <a16:creationId xmlns:a16="http://schemas.microsoft.com/office/drawing/2014/main" id="{A72CAD56-4C2A-417F-B3B0-89F61CA6C83A}"/>
+                <a16:creationId xmlns:a16="http://schemas.microsoft.com/office/drawing/2014/main" id="{39299525-AE35-4F74-8A4A-3E49BD564C32}"/>
               </a:ext>
             </a:extLst>
           </p:cNvPr>
@@ -3372,7 +3372,7 @@
           <p:cNvPr id="12" name="cell-3-0">
             <a:extLst xmlns:a="http://schemas.openxmlformats.org/drawingml/2006/main">
               <a:ext uri="{FF2B5EF4-FFF2-40B4-BE49-F238E27FC236}">
-                <a16:creationId xmlns:a16="http://schemas.microsoft.com/office/drawing/2014/main" id="{3275F01F-CBC0-4560-9AB4-CD5F77ADF716}"/>
+                <a16:creationId xmlns:a16="http://schemas.microsoft.com/office/drawing/2014/main" id="{3D71ACE7-DEEB-464A-A6ED-8EB36E96FE09}"/>
               </a:ext>
             </a:extLst>
           </p:cNvPr>
@@ -3434,7 +3434,7 @@
           <p:cNvPr id="13" name="cell-3-1">
             <a:extLst xmlns:a="http://schemas.openxmlformats.org/drawingml/2006/main">
               <a:ext uri="{FF2B5EF4-FFF2-40B4-BE49-F238E27FC236}">
-                <a16:creationId xmlns:a16="http://schemas.microsoft.com/office/drawing/2014/main" id="{01DECD9E-2BD3-46D5-AE74-E81EBBAE7326}"/>
+                <a16:creationId xmlns:a16="http://schemas.microsoft.com/office/drawing/2014/main" id="{BED8197C-41DB-435F-A19B-6985EE5DBDCB}"/>
               </a:ext>
             </a:extLst>
           </p:cNvPr>
@@ -3496,7 +3496,7 @@
           <p:cNvPr id="14" name="cell-3-2">
             <a:extLst xmlns:a="http://schemas.openxmlformats.org/drawingml/2006/main">
               <a:ext uri="{FF2B5EF4-FFF2-40B4-BE49-F238E27FC236}">
-                <a16:creationId xmlns:a16="http://schemas.microsoft.com/office/drawing/2014/main" id="{3E8EFAF8-348F-46AA-988B-819E25F068C6}"/>
+                <a16:creationId xmlns:a16="http://schemas.microsoft.com/office/drawing/2014/main" id="{1FF532C7-CCFC-4AFA-94E9-84332865FCFF}"/>
               </a:ext>
             </a:extLst>
           </p:cNvPr>
@@ -3556,7 +3556,7 @@
     </p:spTree>
     <p:extLst>
       <p:ext uri="{BB962C8B-B14F-4D97-AF65-F5344CB8AC3E}">
-        <p14:creationId xmlns:p14="http://schemas.microsoft.com/office/powerpoint/2010/main" val="591211724"/>
+        <p14:creationId xmlns:p14="http://schemas.microsoft.com/office/powerpoint/2010/main" val="1916973311"/>
       </p:ext>
     </p:extLst>
   </p:cSld>
@@ -3587,7 +3587,7 @@
           <p:cNvPr id="12" name="title-5">
             <a:extLst xmlns:a="http://schemas.openxmlformats.org/drawingml/2006/main">
               <a:ext uri="{FF2B5EF4-FFF2-40B4-BE49-F238E27FC236}">
-                <a16:creationId xmlns:a16="http://schemas.microsoft.com/office/drawing/2014/main" id="{34A3AAE0-9E8A-4721-975C-07972E6BD76E}"/>
+                <a16:creationId xmlns:a16="http://schemas.microsoft.com/office/drawing/2014/main" id="{427F5156-FC39-4DA3-A599-C8813201553A}"/>
               </a:ext>
             </a:extLst>
           </p:cNvPr>
@@ -3645,7 +3645,7 @@
           <p:cNvPr id="2" name="number-5">
             <a:extLst xmlns:a="http://schemas.openxmlformats.org/drawingml/2006/main">
               <a:ext uri="{FF2B5EF4-FFF2-40B4-BE49-F238E27FC236}">
-                <a16:creationId xmlns:a16="http://schemas.microsoft.com/office/drawing/2014/main" id="{E62368BD-3575-4005-9196-5F369B6724D7}"/>
+                <a16:creationId xmlns:a16="http://schemas.microsoft.com/office/drawing/2014/main" id="{4C569912-86E6-4B92-9F61-D5069FA51680}"/>
               </a:ext>
             </a:extLst>
           </p:cNvPr>
@@ -3703,7 +3703,7 @@
           <p:cNvPr id="3" name="stat-panel-0">
             <a:extLst xmlns:a="http://schemas.openxmlformats.org/drawingml/2006/main">
               <a:ext uri="{FF2B5EF4-FFF2-40B4-BE49-F238E27FC236}">
-                <a16:creationId xmlns:a16="http://schemas.microsoft.com/office/drawing/2014/main" id="{7FB5ABD2-29A6-4B87-9991-B69A353DFC90}"/>
+                <a16:creationId xmlns:a16="http://schemas.microsoft.com/office/drawing/2014/main" id="{01DD58B6-8B57-4D0A-9716-D9A3D78B3160}"/>
               </a:ext>
             </a:extLst>
           </p:cNvPr>
@@ -3734,7 +3734,7 @@
           <p:cNvPr id="4" name="stat-0">
             <a:extLst xmlns:a="http://schemas.openxmlformats.org/drawingml/2006/main">
               <a:ext uri="{FF2B5EF4-FFF2-40B4-BE49-F238E27FC236}">
-                <a16:creationId xmlns:a16="http://schemas.microsoft.com/office/drawing/2014/main" id="{53E7D76B-63D5-4116-9AD4-94CEBA3CE63C}"/>
+                <a16:creationId xmlns:a16="http://schemas.microsoft.com/office/drawing/2014/main" id="{11DE106F-90F9-44C2-8B94-0E0CBCADE23E}"/>
               </a:ext>
             </a:extLst>
           </p:cNvPr>
@@ -3792,7 +3792,7 @@
           <p:cNvPr id="5" name="stat-caption-0">
             <a:extLst xmlns:a="http://schemas.openxmlformats.org/drawingml/2006/main">
               <a:ext uri="{FF2B5EF4-FFF2-40B4-BE49-F238E27FC236}">
-                <a16:creationId xmlns:a16="http://schemas.microsoft.com/office/drawing/2014/main" id="{A8E1EB90-6340-4558-8F5C-1B6C3ABAFD25}"/>
+                <a16:creationId xmlns:a16="http://schemas.microsoft.com/office/drawing/2014/main" id="{532A16EE-7C1B-4115-AEB4-1F815C4B4801}"/>
               </a:ext>
             </a:extLst>
           </p:cNvPr>
@@ -3850,7 +3850,7 @@
           <p:cNvPr id="6" name="stat-panel-1">
             <a:extLst xmlns:a="http://schemas.openxmlformats.org/drawingml/2006/main">
               <a:ext uri="{FF2B5EF4-FFF2-40B4-BE49-F238E27FC236}">
-                <a16:creationId xmlns:a16="http://schemas.microsoft.com/office/drawing/2014/main" id="{8B0435B6-D179-430F-8839-5C1E0698904F}"/>
+                <a16:creationId xmlns:a16="http://schemas.microsoft.com/office/drawing/2014/main" id="{FD704BA1-E1DF-49B0-BF50-D1119615AB91}"/>
               </a:ext>
             </a:extLst>
           </p:cNvPr>
@@ -3881,7 +3881,7 @@
           <p:cNvPr id="7" name="stat-1">
             <a:extLst xmlns:a="http://schemas.openxmlformats.org/drawingml/2006/main">
               <a:ext uri="{FF2B5EF4-FFF2-40B4-BE49-F238E27FC236}">
-                <a16:creationId xmlns:a16="http://schemas.microsoft.com/office/drawing/2014/main" id="{66F43029-E234-4D06-A4B1-F21D7379ECE0}"/>
+                <a16:creationId xmlns:a16="http://schemas.microsoft.com/office/drawing/2014/main" id="{B2067A3E-BCF2-4916-A0C2-461C75AADDCE}"/>
               </a:ext>
             </a:extLst>
           </p:cNvPr>
@@ -3939,7 +3939,7 @@
           <p:cNvPr id="8" name="stat-caption-1">
             <a:extLst xmlns:a="http://schemas.openxmlformats.org/drawingml/2006/main">
               <a:ext uri="{FF2B5EF4-FFF2-40B4-BE49-F238E27FC236}">
-                <a16:creationId xmlns:a16="http://schemas.microsoft.com/office/drawing/2014/main" id="{93F57D78-7AA2-4EB1-BA3F-BDB22D06826B}"/>
+                <a16:creationId xmlns:a16="http://schemas.microsoft.com/office/drawing/2014/main" id="{D8239DBF-4E9F-47E9-B37B-7252FAB60174}"/>
               </a:ext>
             </a:extLst>
           </p:cNvPr>
@@ -3997,7 +3997,7 @@
           <p:cNvPr id="9" name="stat-panel-2">
             <a:extLst xmlns:a="http://schemas.openxmlformats.org/drawingml/2006/main">
               <a:ext uri="{FF2B5EF4-FFF2-40B4-BE49-F238E27FC236}">
-                <a16:creationId xmlns:a16="http://schemas.microsoft.com/office/drawing/2014/main" id="{55553400-1989-4927-B2EB-D1D8F7282B81}"/>
+                <a16:creationId xmlns:a16="http://schemas.microsoft.com/office/drawing/2014/main" id="{9D216D21-BB00-4EDD-815C-E7357A5CC489}"/>
               </a:ext>
             </a:extLst>
           </p:cNvPr>
@@ -4028,7 +4028,7 @@
           <p:cNvPr id="10" name="stat-2">
             <a:extLst xmlns:a="http://schemas.openxmlformats.org/drawingml/2006/main">
               <a:ext uri="{FF2B5EF4-FFF2-40B4-BE49-F238E27FC236}">
-                <a16:creationId xmlns:a16="http://schemas.microsoft.com/office/drawing/2014/main" id="{CD05045F-6667-4C25-AA9D-BC562E4A002E}"/>
+                <a16:creationId xmlns:a16="http://schemas.microsoft.com/office/drawing/2014/main" id="{D99D769C-1B7B-4C86-9EDB-F56F017E5478}"/>
               </a:ext>
             </a:extLst>
           </p:cNvPr>
@@ -4086,7 +4086,7 @@
           <p:cNvPr id="11" name="stat-caption-2">
             <a:extLst xmlns:a="http://schemas.openxmlformats.org/drawingml/2006/main">
               <a:ext uri="{FF2B5EF4-FFF2-40B4-BE49-F238E27FC236}">
-                <a16:creationId xmlns:a16="http://schemas.microsoft.com/office/drawing/2014/main" id="{04383100-D036-41F4-BE96-7086DA225C73}"/>
+                <a16:creationId xmlns:a16="http://schemas.microsoft.com/office/drawing/2014/main" id="{0B09C649-15E8-4C75-93E9-383AF0716D12}"/>
               </a:ext>
             </a:extLst>
           </p:cNvPr>
@@ -4142,7 +4142,7 @@
     </p:spTree>
     <p:extLst>
       <p:ext uri="{BB962C8B-B14F-4D97-AF65-F5344CB8AC3E}">
-        <p14:creationId xmlns:p14="http://schemas.microsoft.com/office/powerpoint/2010/main" val="761193007"/>
+        <p14:creationId xmlns:p14="http://schemas.microsoft.com/office/powerpoint/2010/main" val="103207987"/>
       </p:ext>
     </p:extLst>
   </p:cSld>
@@ -4173,7 +4173,7 @@
           <p:cNvPr id="10" name="title-6">
             <a:extLst xmlns:a="http://schemas.openxmlformats.org/drawingml/2006/main">
               <a:ext uri="{FF2B5EF4-FFF2-40B4-BE49-F238E27FC236}">
-                <a16:creationId xmlns:a16="http://schemas.microsoft.com/office/drawing/2014/main" id="{68DF847C-CE0E-4965-9294-423F2FB3D8EA}"/>
+                <a16:creationId xmlns:a16="http://schemas.microsoft.com/office/drawing/2014/main" id="{19A93F43-873D-4A13-AF1C-975E1C0F2298}"/>
               </a:ext>
             </a:extLst>
           </p:cNvPr>
@@ -4231,7 +4231,7 @@
           <p:cNvPr id="2" name="number-6">
             <a:extLst xmlns:a="http://schemas.openxmlformats.org/drawingml/2006/main">
               <a:ext uri="{FF2B5EF4-FFF2-40B4-BE49-F238E27FC236}">
-                <a16:creationId xmlns:a16="http://schemas.microsoft.com/office/drawing/2014/main" id="{32ABBBBA-730A-4895-8B83-E2C0C526E8AF}"/>
+                <a16:creationId xmlns:a16="http://schemas.microsoft.com/office/drawing/2014/main" id="{49EEACF3-F4FB-467D-A70F-552A5593D045}"/>
               </a:ext>
             </a:extLst>
           </p:cNvPr>
@@ -4289,7 +4289,7 @@
           <p:cNvPr id="3" name="step-num-0">
             <a:extLst xmlns:a="http://schemas.openxmlformats.org/drawingml/2006/main">
               <a:ext uri="{FF2B5EF4-FFF2-40B4-BE49-F238E27FC236}">
-                <a16:creationId xmlns:a16="http://schemas.microsoft.com/office/drawing/2014/main" id="{6C189C4F-79BC-4D95-95C5-CCC6C5AF14E5}"/>
+                <a16:creationId xmlns:a16="http://schemas.microsoft.com/office/drawing/2014/main" id="{5A8ACB70-1C5C-44ED-9FEB-290395939FA5}"/>
               </a:ext>
             </a:extLst>
           </p:cNvPr>
@@ -4349,7 +4349,7 @@
           <p:cNvPr id="4" name="step-0">
             <a:extLst xmlns:a="http://schemas.openxmlformats.org/drawingml/2006/main">
               <a:ext uri="{FF2B5EF4-FFF2-40B4-BE49-F238E27FC236}">
-                <a16:creationId xmlns:a16="http://schemas.microsoft.com/office/drawing/2014/main" id="{97656E5F-32F7-4610-9705-E5C9702A46D2}"/>
+                <a16:creationId xmlns:a16="http://schemas.microsoft.com/office/drawing/2014/main" id="{F3402A82-AD06-4A09-AF2F-E37952B83F4A}"/>
               </a:ext>
             </a:extLst>
           </p:cNvPr>
@@ -4407,7 +4407,7 @@
           <p:cNvPr id="5" name="step-num-1">
             <a:extLst xmlns:a="http://schemas.openxmlformats.org/drawingml/2006/main">
               <a:ext uri="{FF2B5EF4-FFF2-40B4-BE49-F238E27FC236}">
-                <a16:creationId xmlns:a16="http://schemas.microsoft.com/office/drawing/2014/main" id="{F4D36D1D-C1DE-4346-8AAA-0B784529CFCB}"/>
+                <a16:creationId xmlns:a16="http://schemas.microsoft.com/office/drawing/2014/main" id="{90557E42-A208-45C0-BDCE-5141A543EAA0}"/>
               </a:ext>
             </a:extLst>
           </p:cNvPr>
@@ -4467,7 +4467,7 @@
           <p:cNvPr id="6" name="step-1">
             <a:extLst xmlns:a="http://schemas.openxmlformats.org/drawingml/2006/main">
               <a:ext uri="{FF2B5EF4-FFF2-40B4-BE49-F238E27FC236}">
-                <a16:creationId xmlns:a16="http://schemas.microsoft.com/office/drawing/2014/main" id="{6701065E-F770-4F28-9E17-5F81ECF5837E}"/>
+                <a16:creationId xmlns:a16="http://schemas.microsoft.com/office/drawing/2014/main" id="{E47F1106-8135-4E91-B101-4F5145D033E5}"/>
               </a:ext>
             </a:extLst>
           </p:cNvPr>
@@ -4525,7 +4525,7 @@
           <p:cNvPr id="7" name="step-num-2">
             <a:extLst xmlns:a="http://schemas.openxmlformats.org/drawingml/2006/main">
               <a:ext uri="{FF2B5EF4-FFF2-40B4-BE49-F238E27FC236}">
-                <a16:creationId xmlns:a16="http://schemas.microsoft.com/office/drawing/2014/main" id="{CEAFFDC1-376E-4D2A-B550-B2BB62D8FF3B}"/>
+                <a16:creationId xmlns:a16="http://schemas.microsoft.com/office/drawing/2014/main" id="{08E13915-281E-4EFA-9952-E92A3EA933A5}"/>
               </a:ext>
             </a:extLst>
           </p:cNvPr>
@@ -4585,7 +4585,7 @@
           <p:cNvPr id="8" name="step-2">
             <a:extLst xmlns:a="http://schemas.openxmlformats.org/drawingml/2006/main">
               <a:ext uri="{FF2B5EF4-FFF2-40B4-BE49-F238E27FC236}">
-                <a16:creationId xmlns:a16="http://schemas.microsoft.com/office/drawing/2014/main" id="{A0531FF2-72CD-4659-8DE0-3A4D1A027480}"/>
+                <a16:creationId xmlns:a16="http://schemas.microsoft.com/office/drawing/2014/main" id="{8895112E-55A9-44A2-A71C-6B1DB7408306}"/>
               </a:ext>
             </a:extLst>
           </p:cNvPr>
@@ -4643,7 +4643,7 @@
           <p:cNvPr id="9" name="result-status">
             <a:extLst xmlns:a="http://schemas.openxmlformats.org/drawingml/2006/main">
               <a:ext uri="{FF2B5EF4-FFF2-40B4-BE49-F238E27FC236}">
-                <a16:creationId xmlns:a16="http://schemas.microsoft.com/office/drawing/2014/main" id="{6F02BDB2-4CBB-46B7-82AE-92E7C0E210C3}"/>
+                <a16:creationId xmlns:a16="http://schemas.microsoft.com/office/drawing/2014/main" id="{E341CBF1-DF50-40B0-B769-5E4C267795F4}"/>
               </a:ext>
             </a:extLst>
           </p:cNvPr>
@@ -4699,7 +4699,7 @@
     </p:spTree>
     <p:extLst>
       <p:ext uri="{BB962C8B-B14F-4D97-AF65-F5344CB8AC3E}">
-        <p14:creationId xmlns:p14="http://schemas.microsoft.com/office/powerpoint/2010/main" val="1768814285"/>
+        <p14:creationId xmlns:p14="http://schemas.microsoft.com/office/powerpoint/2010/main" val="789611446"/>
       </p:ext>
     </p:extLst>
   </p:cSld>

</xml_diff>